<commit_message>
Informe técnico en docs/, sección de entregables y enlace al repositorio en la presentación
Co-Authored-By: Claude Opus 5.5 <noreply@anthropic.com>
</commit_message>
<xml_diff>
--- a/docs/presentacion/presentacion-ml.pptx
+++ b/docs/presentacion/presentacion-ml.pptx
@@ -4,6 +4,9 @@
   <p:sldMasterIdLst>
     <p:sldMasterId id="2147483648" r:id="rId1"/>
   </p:sldMasterIdLst>
+  <p:notesMasterIdLst>
+    <p:notesMasterId r:id="rId9"/>
+  </p:notesMasterIdLst>
   <p:sldIdLst>
     <p:sldId id="256" r:id="rId2"/>
     <p:sldId id="257" r:id="rId3"/>
@@ -13,9 +16,6 @@
     <p:sldId id="261" r:id="rId7"/>
     <p:sldId id="262" r:id="rId8"/>
   </p:sldIdLst>
-  <p:notesMasterIdLst>
-    <p:notesMasterId r:id="rId9"/>
-  </p:notesMasterIdLst>
   <p:sldSz cx="12192000" cy="6858000"/>
   <p:notesSz cx="6858000" cy="12192000"/>
   <p:defaultTextStyle>
@@ -113,28 +113,28 @@
   <p:extLst>
     <p:ext uri="{521415D9-36F7-43E2-AB2F-B90AF26B5E84}">
       <p14:sectionLst xmlns:p14="http://schemas.microsoft.com/office/powerpoint/2010/main">
-        <p14:section name="Introducción" id="{3b969a0f-f907-2549-74b9-4e7189f3324f}">
+        <p14:section name="Introducción" id="{3B969A0F-F907-2549-74B9-4E7189F3324F}">
           <p14:sldIdLst>
             <p14:sldId id="256"/>
           </p14:sldIdLst>
         </p14:section>
-        <p14:section name="Solución" id="{4b4ac7b5-e628-32c1-40fb-f3843c751f7c}">
+        <p14:section name="Solución" id="{4B4AC7B5-E628-32C1-40FB-F3843C751F7C}">
           <p14:sldIdLst>
             <p14:sldId id="257"/>
           </p14:sldIdLst>
         </p14:section>
-        <p14:section name="Resultados" id="{72fd74d7-a034-332f-f8fc-ce44a6f94efc}">
+        <p14:section name="Resultados" id="{72FD74D7-A034-332F-F8FC-CE44A6F94EFC}">
           <p14:sldIdLst>
             <p14:sldId id="258"/>
           </p14:sldIdLst>
         </p14:section>
-        <p14:section name="Cierre" id="{ecc7fe63-88a0-57e8-ee01-9d4e7b2caa5e}">
+        <p14:section name="Cierre" id="{ECC7FE63-88A0-57E8-EE01-9D4E7B2CAA5E}">
           <p14:sldIdLst>
             <p14:sldId id="259"/>
             <p14:sldId id="260"/>
           </p14:sldIdLst>
         </p14:section>
-        <p14:section name="Respaldo" id="{649f14e9-4ebd-e938-25e4-4239064a9e6a}">
+        <p14:section name="Respaldo" id="{649F14E9-4EBD-E938-25E4-4239064A9E6A}">
           <p14:sldIdLst>
             <p14:sldId id="261"/>
             <p14:sldId id="262"/>
@@ -150,9 +150,11 @@
 </file>
 
 <file path=ppt/charts/chart1.xml><?xml version="1.0" encoding="utf-8"?>
-<c:chartSpace xmlns:c="http://schemas.openxmlformats.org/drawingml/2006/chart" xmlns:a="http://schemas.openxmlformats.org/drawingml/2006/main" xmlns:r="http://schemas.openxmlformats.org/officeDocument/2006/relationships">
+<c:chartSpace xmlns:c="http://schemas.openxmlformats.org/drawingml/2006/chart" xmlns:a="http://schemas.openxmlformats.org/drawingml/2006/main" xmlns:r="http://schemas.openxmlformats.org/officeDocument/2006/relationships" xmlns:c16r2="http://schemas.microsoft.com/office/drawing/2015/06/chart">
   <c:date1904 val="0"/>
+  <c:lang val="en-US"/>
   <c:roundedCorners val="1"/>
+  <c:style val="2"/>
   <c:chart>
     <c:title>
       <c:tx>
@@ -169,7 +171,7 @@
               </a:defRPr>
             </a:pPr>
             <a:r>
-              <a:rPr sz="1400" b="0" i="0" u="none" strike="noStrike">
+              <a:rPr lang="es-ES" sz="1400" b="0" i="0" u="none" strike="noStrike">
                 <a:solidFill>
                   <a:srgbClr val="1B2A2F"/>
                 </a:solidFill>
@@ -180,7 +182,6 @@
           </a:p>
         </c:rich>
       </c:tx>
-      <c:layout/>
       <c:overlay val="0"/>
     </c:title>
     <c:autoTitleDeleted val="0"/>
@@ -211,40 +212,15 @@
             <a:effectLst/>
           </c:spPr>
           <c:invertIfNegative val="0"/>
-          <c:dLbls>
-            <c:numFmt formatCode="0.0&quot;%&quot;" sourceLinked="0"/>
-            <c:txPr>
-              <a:bodyPr/>
-              <a:lstStyle/>
-              <a:p>
-                <a:pPr>
-                  <a:defRPr b="1" i="0" strike="noStrike" sz="1600" u="none">
-                    <a:solidFill>
-                      <a:srgbClr val="1B2A2F"/>
-                    </a:solidFill>
-                    <a:latin typeface="+mn-lt"/>
-                  </a:defRPr>
-                </a:pPr>
-              </a:p>
-            </c:txPr>
-            <c:showLegendKey val="0"/>
-            <c:showVal val="1"/>
-            <c:showCatName val="0"/>
-            <c:showSerName val="0"/>
-            <c:showPercent val="0"/>
-            <c:showBubbleSize val="0"/>
-            <c:showLeaderLines val="0"/>
-          </c:dLbls>
           <c:dPt>
             <c:idx val="0"/>
             <c:invertIfNegative val="0"/>
             <c:bubble3D val="0"/>
-            <c:spPr>
-              <a:solidFill>
-                <a:srgbClr val="9AA5A3"/>
-              </a:solidFill>
-              <a:effectLst/>
-            </c:spPr>
+            <c:extLst>
+              <c:ext xmlns:c16="http://schemas.microsoft.com/office/drawing/2014/chart" uri="{C3380CC4-5D6E-409C-BE32-E72D297353CC}">
+                <c16:uniqueId val="{00000001-3FA3-4502-959A-3307F2F92F37}"/>
+              </c:ext>
+            </c:extLst>
           </c:dPt>
           <c:dPt>
             <c:idx val="1"/>
@@ -256,6 +232,11 @@
               </a:solidFill>
               <a:effectLst/>
             </c:spPr>
+            <c:extLst>
+              <c:ext xmlns:c16="http://schemas.microsoft.com/office/drawing/2014/chart" uri="{C3380CC4-5D6E-409C-BE32-E72D297353CC}">
+                <c16:uniqueId val="{00000003-3FA3-4502-959A-3307F2F92F37}"/>
+              </c:ext>
+            </c:extLst>
           </c:dPt>
           <c:dPt>
             <c:idx val="2"/>
@@ -267,25 +248,65 @@
               </a:solidFill>
               <a:effectLst/>
             </c:spPr>
+            <c:extLst>
+              <c:ext xmlns:c16="http://schemas.microsoft.com/office/drawing/2014/chart" uri="{C3380CC4-5D6E-409C-BE32-E72D297353CC}">
+                <c16:uniqueId val="{00000005-3FA3-4502-959A-3307F2F92F37}"/>
+              </c:ext>
+            </c:extLst>
           </c:dPt>
+          <c:dLbls>
+            <c:numFmt formatCode="0.0&quot;%&quot;" sourceLinked="0"/>
+            <c:spPr>
+              <a:noFill/>
+              <a:ln>
+                <a:noFill/>
+              </a:ln>
+              <a:effectLst/>
+            </c:spPr>
+            <c:txPr>
+              <a:bodyPr/>
+              <a:lstStyle/>
+              <a:p>
+                <a:pPr>
+                  <a:defRPr sz="1600" b="1" i="0" u="none" strike="noStrike">
+                    <a:solidFill>
+                      <a:srgbClr val="1B2A2F"/>
+                    </a:solidFill>
+                    <a:latin typeface="+mn-lt"/>
+                  </a:defRPr>
+                </a:pPr>
+                <a:endParaRPr lang="en-US"/>
+              </a:p>
+            </c:txPr>
+            <c:showLegendKey val="0"/>
+            <c:showVal val="1"/>
+            <c:showCatName val="0"/>
+            <c:showSerName val="0"/>
+            <c:showPercent val="0"/>
+            <c:showBubbleSize val="0"/>
+            <c:showLeaderLines val="0"/>
+            <c:extLst>
+              <c:ext xmlns:c15="http://schemas.microsoft.com/office/drawing/2012/chart" uri="{CE6537A1-D6FC-4f65-9D91-7224C49458BB}">
+                <c15:showLeaderLines val="0"/>
+              </c:ext>
+            </c:extLst>
+          </c:dLbls>
           <c:cat>
-            <c:multiLvlStrRef>
+            <c:strRef>
               <c:f>Sheet1!$A$2:$A$4</c:f>
-              <c:multiLvlStrCache>
+              <c:strCache>
                 <c:ptCount val="3"/>
-                <c:lvl>
-                  <c:pt idx="0">
-                    <c:v>Línea base: ResNet50</c:v>
-                  </c:pt>
-                  <c:pt idx="1">
-                    <c:v>ResNet50 + siamesa</c:v>
-                  </c:pt>
-                  <c:pt idx="2">
-                    <c:v>ResNet50 + PCA + LDA</c:v>
-                  </c:pt>
-                </c:lvl>
-              </c:multiLvlStrCache>
-            </c:multiLvlStrRef>
+                <c:pt idx="0">
+                  <c:v>Línea base: ResNet50</c:v>
+                </c:pt>
+                <c:pt idx="1">
+                  <c:v>ResNet50 + siamesa</c:v>
+                </c:pt>
+                <c:pt idx="2">
+                  <c:v>ResNet50 + PCA + LDA</c:v>
+                </c:pt>
+              </c:strCache>
+            </c:strRef>
           </c:cat>
           <c:val>
             <c:numRef>
@@ -305,36 +326,23 @@
               </c:numCache>
             </c:numRef>
           </c:val>
+          <c:extLst>
+            <c:ext xmlns:c16="http://schemas.microsoft.com/office/drawing/2014/chart" uri="{C3380CC4-5D6E-409C-BE32-E72D297353CC}">
+              <c16:uniqueId val="{00000006-3FA3-4502-959A-3307F2F92F37}"/>
+            </c:ext>
+          </c:extLst>
         </c:ser>
         <c:dLbls>
-          <c:numFmt formatCode="0.0&quot;%&quot;" sourceLinked="0"/>
-          <c:txPr>
-            <a:bodyPr/>
-            <a:lstStyle/>
-            <a:p>
-              <a:pPr>
-                <a:defRPr b="1" i="0" strike="noStrike" sz="1600" u="none">
-                  <a:solidFill>
-                    <a:srgbClr val="1B2A2F"/>
-                  </a:solidFill>
-                  <a:latin typeface="+mn-lt"/>
-                </a:defRPr>
-              </a:pPr>
-            </a:p>
-          </c:txPr>
           <c:showLegendKey val="0"/>
           <c:showVal val="1"/>
           <c:showCatName val="0"/>
           <c:showSerName val="0"/>
           <c:showPercent val="0"/>
           <c:showBubbleSize val="0"/>
-          <c:showLeaderLines val="0"/>
         </c:dLbls>
         <c:gapWidth val="60"/>
-        <c:overlap val="0"/>
         <c:axId val="2094734554"/>
         <c:axId val="2094734552"/>
-        <c:axId val="2094734556"/>
       </c:barChart>
       <c:catAx>
         <c:axId val="2094734554"/>
@@ -375,6 +383,7 @@
         <c:crosses val="autoZero"/>
         <c:auto val="1"/>
         <c:lblAlgn val="ctr"/>
+        <c:lblOffset val="100"/>
         <c:noMultiLvlLbl val="1"/>
       </c:catAx>
       <c:valAx>
@@ -440,6 +449,7 @@
     </c:plotArea>
     <c:plotVisOnly val="1"/>
     <c:dispBlanksAs val="span"/>
+    <c:showDLblsOverMax val="1"/>
   </c:chart>
   <c:spPr>
     <a:noFill/>
@@ -476,234 +486,10 @@
           <a:chExt cx="0" cy="0"/>
         </a:xfrm>
       </p:grpSpPr>
-      <p:sp>
-        <p:nvSpPr>
-          <p:cNvPr id="2" name="Header Placeholder 1"/>
-          <p:cNvSpPr>
-            <a:spLocks noGrp="1"/>
-          </p:cNvSpPr>
-          <p:nvPr>
-            <p:ph type="hdr" sz="quarter"/>
-          </p:nvPr>
-        </p:nvSpPr>
-        <p:spPr>
-          <a:xfrm>
-            <a:off x="0" y="0"/>
-            <a:ext cx="2971800" cy="458788"/>
-          </a:xfrm>
-          <a:prstGeom prst="rect">
-            <a:avLst/>
-          </a:prstGeom>
-        </p:spPr>
-        <p:txBody>
-          <a:bodyPr vert="horz" lIns="91440" tIns="45720" rIns="91440" bIns="45720" rtlCol="0"/>
-          <a:lstStyle>
-            <a:lvl1pPr algn="l">
-              <a:defRPr sz="1200"/>
-            </a:lvl1pPr>
-          </a:lstStyle>
-          <a:p>
-            <a:endParaRPr lang="en-US"/>
-          </a:p>
-        </p:txBody>
-      </p:sp>
-      <p:sp>
-        <p:nvSpPr>
-          <p:cNvPr id="3" name="Date Placeholder 2"/>
-          <p:cNvSpPr>
-            <a:spLocks noGrp="1"/>
-          </p:cNvSpPr>
-          <p:nvPr>
-            <p:ph type="dt" idx="1"/>
-          </p:nvPr>
-        </p:nvSpPr>
-        <p:spPr>
-          <a:xfrm>
-            <a:off x="3884613" y="0"/>
-            <a:ext cx="2971800" cy="458788"/>
-          </a:xfrm>
-          <a:prstGeom prst="rect">
-            <a:avLst/>
-          </a:prstGeom>
-        </p:spPr>
-        <p:txBody>
-          <a:bodyPr vert="horz" lIns="91440" tIns="45720" rIns="91440" bIns="45720" rtlCol="0"/>
-          <a:lstStyle>
-            <a:lvl1pPr algn="r">
-              <a:defRPr sz="1200"/>
-            </a:lvl1pPr>
-          </a:lstStyle>
-          <a:p>
-            <a:fld id="{5282F153-3F37-0F45-9E97-73ACFA13230C}" type="datetimeFigureOut">
-              <a:rPr lang="en-US"/>
-              <a:t>7/23/19</a:t>
-            </a:fld>
-            <a:endParaRPr lang="en-US"/>
-          </a:p>
-        </p:txBody>
-      </p:sp>
-      <p:sp>
-        <p:nvSpPr>
-          <p:cNvPr id="4" name="Slide Image Placeholder 3"/>
-          <p:cNvSpPr>
-            <a:spLocks noGrp="1" noRot="1" noChangeAspect="1"/>
-          </p:cNvSpPr>
-          <p:nvPr>
-            <p:ph type="sldImg" idx="2"/>
-          </p:nvPr>
-        </p:nvSpPr>
-        <p:spPr>
-          <a:xfrm>
-            <a:off x="685800" y="1143000"/>
-            <a:ext cx="5486400" cy="3086100"/>
-          </a:xfrm>
-          <a:prstGeom prst="rect">
-            <a:avLst/>
-          </a:prstGeom>
-          <a:noFill/>
-          <a:ln w="12700">
-            <a:solidFill>
-              <a:prstClr val="black"/>
-            </a:solidFill>
-          </a:ln>
-        </p:spPr>
-        <p:txBody>
-          <a:bodyPr vert="horz" lIns="91440" tIns="45720" rIns="91440" bIns="45720" rtlCol="0" anchor="ctr"/>
-          <a:lstStyle/>
-          <a:p>
-            <a:endParaRPr lang="en-US"/>
-          </a:p>
-        </p:txBody>
-      </p:sp>
-      <p:sp>
-        <p:nvSpPr>
-          <p:cNvPr id="5" name="Notes Placeholder 4"/>
-          <p:cNvSpPr>
-            <a:spLocks noGrp="1"/>
-          </p:cNvSpPr>
-          <p:nvPr>
-            <p:ph type="body" sz="quarter" idx="3"/>
-          </p:nvPr>
-        </p:nvSpPr>
-        <p:spPr>
-          <a:xfrm>
-            <a:off x="685800" y="4400550"/>
-            <a:ext cx="5486400" cy="3600450"/>
-          </a:xfrm>
-          <a:prstGeom prst="rect">
-            <a:avLst/>
-          </a:prstGeom>
-        </p:spPr>
-        <p:txBody>
-          <a:bodyPr vert="horz" lIns="91440" tIns="45720" rIns="91440" bIns="45720" rtlCol="0"/>
-          <a:lstStyle/>
-          <a:p>
-            <a:pPr lvl="0"/>
-            <a:r>
-              <a:rPr lang="en-US"/>
-              <a:t>Click to edit Master text styles</a:t>
-            </a:r>
-          </a:p>
-          <a:p>
-            <a:pPr lvl="1"/>
-            <a:r>
-              <a:rPr lang="en-US"/>
-              <a:t>Second level</a:t>
-            </a:r>
-          </a:p>
-          <a:p>
-            <a:pPr lvl="2"/>
-            <a:r>
-              <a:rPr lang="en-US"/>
-              <a:t>Third level</a:t>
-            </a:r>
-          </a:p>
-          <a:p>
-            <a:pPr lvl="3"/>
-            <a:r>
-              <a:rPr lang="en-US"/>
-              <a:t>Fourth level</a:t>
-            </a:r>
-          </a:p>
-          <a:p>
-            <a:pPr lvl="4"/>
-            <a:r>
-              <a:rPr lang="en-US"/>
-              <a:t>Fifth level</a:t>
-            </a:r>
-          </a:p>
-        </p:txBody>
-      </p:sp>
-      <p:sp>
-        <p:nvSpPr>
-          <p:cNvPr id="6" name="Footer Placeholder 5"/>
-          <p:cNvSpPr>
-            <a:spLocks noGrp="1"/>
-          </p:cNvSpPr>
-          <p:nvPr>
-            <p:ph type="ftr" sz="quarter" idx="4"/>
-          </p:nvPr>
-        </p:nvSpPr>
-        <p:spPr>
-          <a:xfrm>
-            <a:off x="0" y="8685213"/>
-            <a:ext cx="2971800" cy="458787"/>
-          </a:xfrm>
-          <a:prstGeom prst="rect">
-            <a:avLst/>
-          </a:prstGeom>
-        </p:spPr>
-        <p:txBody>
-          <a:bodyPr vert="horz" lIns="91440" tIns="45720" rIns="91440" bIns="45720" rtlCol="0" anchor="b"/>
-          <a:lstStyle>
-            <a:lvl1pPr algn="l">
-              <a:defRPr sz="1200"/>
-            </a:lvl1pPr>
-          </a:lstStyle>
-          <a:p>
-            <a:endParaRPr lang="en-US"/>
-          </a:p>
-        </p:txBody>
-      </p:sp>
-      <p:sp>
-        <p:nvSpPr>
-          <p:cNvPr id="7" name="Slide Number Placeholder 6"/>
-          <p:cNvSpPr>
-            <a:spLocks noGrp="1"/>
-          </p:cNvSpPr>
-          <p:nvPr>
-            <p:ph type="sldNum" sz="quarter" idx="5"/>
-          </p:nvPr>
-        </p:nvSpPr>
-        <p:spPr>
-          <a:xfrm>
-            <a:off x="3884613" y="8685213"/>
-            <a:ext cx="2971800" cy="458787"/>
-          </a:xfrm>
-          <a:prstGeom prst="rect">
-            <a:avLst/>
-          </a:prstGeom>
-        </p:spPr>
-        <p:txBody>
-          <a:bodyPr vert="horz" lIns="91440" tIns="45720" rIns="91440" bIns="45720" rtlCol="0" anchor="b"/>
-          <a:lstStyle>
-            <a:lvl1pPr algn="r">
-              <a:defRPr sz="1200"/>
-            </a:lvl1pPr>
-          </a:lstStyle>
-          <a:p>
-            <a:fld id="{CE5E9CC1-C706-0F49-92D6-E571CC5EEA8F}" type="slidenum">
-              <a:rPr lang="en-US"/>
-              <a:t>‹#›</a:t>
-            </a:fld>
-            <a:endParaRPr lang="en-US"/>
-          </a:p>
-        </p:txBody>
-      </p:sp>
     </p:spTree>
     <p:extLst>
       <p:ext uri="{BB962C8B-B14F-4D97-AF65-F5344CB8AC3E}">
-        <p14:creationId xmlns:p14="http://schemas.microsoft.com/office/powerpoint/2010/main" val="1024086991"/>
+        <p14:creationId xmlns:p14="http://schemas.microsoft.com/office/powerpoint/2010/main" val="2813823842"/>
       </p:ext>
     </p:extLst>
   </p:cSld>
@@ -849,15 +635,12 @@
           <a:p>
             <a:r>
               <a:rPr lang="en-US" dirty="0"/>
-              <a:t>TIEMPO: ~20 segundos
-QUÉ DECIR:
-"Buenos días. Soy Imer Coaguila. Mi proyecto se llama 'Encontré una mascota'. Es un microservicio de Machine Learning para Pets Location, la plataforma de mi tesis, que identifica a un perro perdido a partir de una foto de su cara y muestra dónde está su collar."
+              <a:t>"Buenos días. Soy Imer Coaguila. Mi proyecto se llama 'Encontré una mascota'. Es un microservicio de Machine Learning para Pets Location, la plataforma de mi tesis, que identifica a un perro perdido a partir de una foto de su cara y muestra dónde está su collar."
 CONCEPTOS:
 - Microservicio: aplicación independiente que se ejecuta sola y ofrece su función a través de una API (aquí, en el puerto 9100).
 - Reidentificación: reconocer al mismo individuo (no la raza) en fotos distintas.
 - DogFaceNet: dataset público de fotos reales de caras de perros (CC BY 4.0); las fotos de la portada son de ahí.</a:t>
             </a:r>
-            <a:endParaRPr lang="en-US" dirty="0"/>
           </a:p>
         </p:txBody>
       </p:sp>
@@ -943,9 +726,7 @@
           <a:p>
             <a:r>
               <a:rPr lang="en-US" dirty="0"/>
-              <a:t>TIEMPO: ~50 segundos
-QUÉ DECIR:
-"El problema: alguien encuentra un perro y no sabe si está registrado ni quién es su dueño.
+              <a:t>"El problema: alguien encuentra un perro y no sabe si está registrado ni quién es su dueño.
 El sistema tiene dos partes. Arriba, el entrenamiento, que se hace una sola vez: tomé 2.517 fotos de 338 perros de DogFaceNet. ResNet50, una red ya entrenada con ImageNet, convierte cada foto en 2.048 números; esa red no la entreno, la reutilizo (en azul oscuro). Lo que sí entreno está en naranja: PCA resume esos números a 512, y LDA, usando a qué perro pertenece cada foto, aprende qué distingue a un perro de otro y deja 128 números. Al final, con otros 113 perros de validación, calculo el umbral.
 Abajo, el uso, que ocurre en cada búsqueda: la foto encontrada pasa por la misma ResNet50 y por el PCA + LDA ya aprendidos, se compara con los 85 perros registrados, se muestran los 3 más parecidos, y si la distancia del primero está bajo el umbral se sugiere al dueño y la ubicación del collar.
 En total usé 4.168 fotos de 564 perros, separados por perro en entrenamiento (338), validación (113) y prueba (113). Así, ningún perro de la prueba se vio antes."
@@ -959,7 +740,6 @@
 - Umbral: distancia máxima para decir "es este perro". Se eligió con validación.
 - Partición por perro: evita la fuga de datos (que el mismo perro esté en entrenamiento y en prueba).</a:t>
             </a:r>
-            <a:endParaRPr lang="en-US" dirty="0"/>
           </a:p>
         </p:txBody>
       </p:sp>
@@ -1045,9 +825,7 @@
           <a:p>
             <a:r>
               <a:rPr lang="en-US" dirty="0"/>
-              <a:t>TIEMPO: ~50 segundos + DEMO 2 minutos
-QUÉ DECIR:
-"Comparé tres métodos con el mismo conjunto de prueba.
+              <a:t>"Comparé tres métodos con el mismo conjunto de prueba.
 La línea base, ResNet50 sin entrenar nada, identifica al perro correcto en primer lugar el 73,2 % de las veces.
 La red siamesa, un modelo de aprendizaje profundo que aprende comparando pares de fotos, llega a 76 %.
 PCA + LDA llega a 83,2 %: 10 puntos más que la línea base. Y el perro correcto está entre los 3 candidatos el 93 % de las veces.
@@ -1075,7 +853,6 @@
 - Red siamesa: modelo de aprendizaje profundo que recibe DOS fotos, las procesa con la misma red (pesos compartidos) y aprende con pares: "mismo perro: acerca sus vectores; perros distintos: aléjalos". La regla de aprendizaje se llama pérdida contrastiva.
 - Por qué se incluyó la siamesa: es el enfoque más usado para verificar si dos fotos son del mismo individuo (rostros, firmas). Sirve para comparar un método clásico (LDA) contra uno de deep learning con las mismas características de ResNet50.</a:t>
             </a:r>
-            <a:endParaRPr lang="en-US" dirty="0"/>
           </a:p>
         </p:txBody>
       </p:sp>
@@ -1161,9 +938,7 @@
           <a:p>
             <a:r>
               <a:rPr lang="en-US" dirty="0"/>
-              <a:t>TIEMPO: ~40 segundos
-QUÉ DECIR:
-"Conclusiones: un método clásico de Machine Learning, LDA, superó a la línea base en 10 puntos. Con solo 338 perros para aprender, LDA calcula la solución directamente con una fórmula, mientras que la red siamesa se sobreajusta en pocas épocas. Y la comparación es confiable porque separé los datos por perro y no ajusté nada con la prueba.
+              <a:t>"Conclusiones: un método clásico de Machine Learning, LDA, superó a la línea base en 10 puntos. Con solo 338 perros para aprender, LDA calcula la solución directamente con una fórmula, mientras que la red siamesa se sobreajusta en pocas épocas. Y la comparación es confiable porque separé los datos por perro y no ajusté nada con la prueba.
 Limitaciones: el umbral aceptó 8,8 % de perros sin registro cuando el objetivo era 5 %, porque no se transfiere perfecto a perros nuevos. El sistema necesita la cara centrada, porque no detecta rostros. Y confunde perros casi idénticos, como estos dos cachorros.
 Con más datos mejora: con 100 perros llega a 84 % y con 338 a casi 88 % en validación; son unos 2 puntos cada vez que se duplica la cantidad de perros."
 CONCEPTOS:
@@ -1172,7 +947,6 @@
 - Shrinkage: ajuste que estabiliza LDA cuando hay pocas fotos para muchas variables.
 - Cambio de dominio: el modelo aprendió con caras recortadas y alineadas; una foto de celular de cuerpo completo es distinta y falla más.</a:t>
             </a:r>
-            <a:endParaRPr lang="en-US" dirty="0"/>
           </a:p>
         </p:txBody>
       </p:sp>
@@ -1258,9 +1032,7 @@
           <a:p>
             <a:r>
               <a:rPr lang="en-US" dirty="0"/>
-              <a:t>TIEMPO: ~20 segundos
-QUÉ DECIR:
-"Todo el código está en el repositorio con el tag v1.0. Con 'python run.py' o con Docker se levanta el sistema completo, y hay 28 pruebas automatizadas que cubren un caso válido, casos difíciles, entradas inválidas y el flujo completo. Muchas gracias, quedo atento a sus preguntas."
+              <a:t>"Todo el código está en el repositorio con el tag v1.0. Con 'python run.py' o con Docker se levanta el sistema completo, y hay 28 pruebas automatizadas que cubren un caso válido, casos difíciles, entradas inválidas y el flujo completo. Muchas gracias, quedo atento a sus preguntas."
 DIAPOSITIVAS DE RESPALDO (ocultas, no se muestran al presentar): 6 = glosario, 7 = preguntas frecuentes. Para ir a una durante la presentación: escribir su número y Enter.
 POSIBLES PREGUNTAS (respuestas cortas):
 Sobre las decisiones
@@ -1286,7 +1058,6 @@
 - ¿Mejora con más datos? Sí: unos 2 puntos de Top-1 cada vez que se duplica la cantidad de perros, cada vez con menos ganancia.
 - ¿Qué mejorarías? Más perros, un detector de rostros y probar extractores más modernos.</a:t>
             </a:r>
-            <a:endParaRPr lang="en-US" dirty="0"/>
           </a:p>
         </p:txBody>
       </p:sp>
@@ -1374,7 +1145,6 @@
               <a:rPr lang="en-US" dirty="0"/>
               <a:t>Diapositiva oculta de respaldo: no aparece al presentar. Si preguntan por un término, ir aquí (en la vista del moderador, escribir el número 6 y Enter).</a:t>
             </a:r>
-            <a:endParaRPr lang="en-US" dirty="0"/>
           </a:p>
         </p:txBody>
       </p:sp>
@@ -1462,7 +1232,6 @@
               <a:rPr lang="en-US" dirty="0"/>
               <a:t>Diapositiva oculta de respaldo con las preguntas más probables. Hay más preguntas y respuestas en las notas de la diapositiva 5.</a:t>
             </a:r>
-            <a:endParaRPr lang="en-US" dirty="0"/>
           </a:p>
         </p:txBody>
       </p:sp>
@@ -1540,6 +1309,7 @@
         <a:solidFill>
           <a:srgbClr val="1F4E4A"/>
         </a:solidFill>
+        <a:effectLst/>
       </p:bgPr>
     </p:bg>
     <p:spTree>
@@ -1559,9 +1329,11 @@
       <p:sp>
         <p:nvSpPr>
           <p:cNvPr id="2" name="Text 0"/>
-          <p:cNvSpPr/>
+          <p:cNvSpPr>
+            <a:spLocks noGrp="1"/>
+          </p:cNvSpPr>
           <p:nvPr>
-            <p:ph idx="100" type="title" hasCustomPrompt="1"/>
+            <p:ph type="title" idx="100" hasCustomPrompt="1"/>
           </p:nvPr>
         </p:nvSpPr>
         <p:spPr>
@@ -1578,7 +1350,7 @@
         <p:txBody>
           <a:bodyPr wrap="square" rtlCol="0"/>
           <a:lstStyle>
-            <a:lvl1pPr algn="l" indent="0" marL="0">
+            <a:lvl1pPr marL="0" indent="0" algn="l">
               <a:buNone/>
               <a:defRPr lang="en-US" sz="4400" b="1" dirty="0">
                 <a:solidFill>
@@ -1588,7 +1360,7 @@
             </a:lvl1pPr>
           </a:lstStyle>
           <a:p>
-            <a:pPr algn="l" indent="0" marL="0">
+            <a:pPr marL="0" indent="0" algn="l">
               <a:buNone/>
             </a:pPr>
             <a:endParaRPr lang="en-US" sz="4400" dirty="0"/>
@@ -1598,9 +1370,11 @@
       <p:sp>
         <p:nvSpPr>
           <p:cNvPr id="3" name="Text 0"/>
-          <p:cNvSpPr/>
+          <p:cNvSpPr>
+            <a:spLocks noGrp="1"/>
+          </p:cNvSpPr>
           <p:nvPr>
-            <p:ph idx="101" type="body" hasCustomPrompt="1"/>
+            <p:ph type="body" idx="101" hasCustomPrompt="1"/>
           </p:nvPr>
         </p:nvSpPr>
         <p:spPr>
@@ -1617,7 +1391,7 @@
         <p:txBody>
           <a:bodyPr wrap="square" rtlCol="0"/>
           <a:lstStyle>
-            <a:lvl1pPr algn="l" indent="0" marL="0">
+            <a:lvl1pPr marL="0" indent="0" algn="l">
               <a:buNone/>
               <a:defRPr lang="en-US" sz="2000" dirty="0">
                 <a:solidFill>
@@ -1627,7 +1401,7 @@
             </a:lvl1pPr>
           </a:lstStyle>
           <a:p>
-            <a:pPr algn="l" indent="0" marL="0">
+            <a:pPr marL="0" indent="0" algn="l">
               <a:buNone/>
             </a:pPr>
             <a:endParaRPr lang="en-US" sz="2000" dirty="0"/>
@@ -1637,9 +1411,11 @@
       <p:sp>
         <p:nvSpPr>
           <p:cNvPr id="4" name="Text 0"/>
-          <p:cNvSpPr/>
+          <p:cNvSpPr>
+            <a:spLocks noGrp="1"/>
+          </p:cNvSpPr>
           <p:nvPr>
-            <p:ph idx="102" type="body" hasCustomPrompt="1"/>
+            <p:ph type="body" idx="102" hasCustomPrompt="1"/>
           </p:nvPr>
         </p:nvSpPr>
         <p:spPr>
@@ -1656,7 +1432,7 @@
         <p:txBody>
           <a:bodyPr wrap="square" rtlCol="0"/>
           <a:lstStyle>
-            <a:lvl1pPr algn="l" indent="0" marL="0">
+            <a:lvl1pPr marL="0" indent="0" algn="l">
               <a:buNone/>
               <a:defRPr lang="en-US" sz="1400" dirty="0">
                 <a:solidFill>
@@ -1666,7 +1442,7 @@
             </a:lvl1pPr>
           </a:lstStyle>
           <a:p>
-            <a:pPr algn="l" indent="0" marL="0">
+            <a:pPr marL="0" indent="0" algn="l">
               <a:buNone/>
             </a:pPr>
             <a:endParaRPr lang="en-US" sz="1400" dirty="0"/>
@@ -1689,6 +1465,7 @@
         <a:solidFill>
           <a:srgbClr val="FFFFFF"/>
         </a:solidFill>
+        <a:effectLst/>
       </p:bgPr>
     </p:bg>
     <p:spTree>
@@ -1708,9 +1485,11 @@
       <p:sp>
         <p:nvSpPr>
           <p:cNvPr id="2" name="Text 0"/>
-          <p:cNvSpPr/>
+          <p:cNvSpPr>
+            <a:spLocks noGrp="1"/>
+          </p:cNvSpPr>
           <p:nvPr>
-            <p:ph idx="100" type="title" hasCustomPrompt="1"/>
+            <p:ph type="title" idx="100" hasCustomPrompt="1"/>
           </p:nvPr>
         </p:nvSpPr>
         <p:spPr>
@@ -1727,7 +1506,7 @@
         <p:txBody>
           <a:bodyPr wrap="square" rtlCol="0"/>
           <a:lstStyle>
-            <a:lvl1pPr indent="0" marL="0">
+            <a:lvl1pPr marL="0" indent="0">
               <a:buNone/>
               <a:defRPr lang="en-US" sz="3200" b="1" dirty="0">
                 <a:solidFill>
@@ -1737,7 +1516,7 @@
             </a:lvl1pPr>
           </a:lstStyle>
           <a:p>
-            <a:pPr indent="0" marL="0">
+            <a:pPr marL="0" indent="0">
               <a:buNone/>
             </a:pPr>
             <a:endParaRPr lang="en-US" sz="3200" dirty="0"/>
@@ -1765,7 +1544,7 @@
           <a:bodyPr wrap="square" lIns="0" tIns="0" rIns="0" bIns="0" rtlCol="0" anchor="ctr"/>
           <a:lstStyle/>
           <a:p>
-            <a:pPr indent="0" marL="0">
+            <a:pPr marL="0" indent="0">
               <a:buNone/>
             </a:pPr>
             <a:r>
@@ -1800,7 +1579,7 @@
           </a:prstGeom>
           <a:extLst>
             <a:ext uri="{C572A759-6A51-4108-AA02-DFA0A04FC94B}">
-              <ma14:wrappingTextBoxFlag xmlns:ma14="http://schemas.microsoft.com/office/mac/drawingml/2011/main" val="0"/>
+              <ma14:wrappingTextBoxFlag xmlns:ma14="http://schemas.microsoft.com/office/mac/drawingml/2011/main" xmlns="" val="0"/>
             </a:ext>
           </a:extLst>
         </p:spPr>
@@ -1818,8 +1597,8 @@
           <a:p>
             <a:pPr algn="r"/>
             <a:fld id="{F7021451-1387-4CA6-816F-3879F97B5CBC}" type="slidenum">
-              <a:rPr b="0" lang="en-US"/>
-              <a:t>1003</a:t>
+              <a:rPr lang="en-US" b="0"/>
+              <a:t>‹#›</a:t>
             </a:fld>
             <a:endParaRPr lang="en-US"/>
           </a:p>
@@ -1836,6 +1615,11 @@
 <file path=ppt/slideMasters/slideMaster1.xml><?xml version="1.0" encoding="utf-8"?>
 <p:sldMaster xmlns:a="http://schemas.openxmlformats.org/drawingml/2006/main" xmlns:r="http://schemas.openxmlformats.org/officeDocument/2006/relationships" xmlns:p="http://schemas.openxmlformats.org/presentationml/2006/main">
   <p:cSld>
+    <p:bg>
+      <p:bgRef idx="1001">
+        <a:schemeClr val="bg1"/>
+      </p:bgRef>
+    </p:bg>
     <p:spTree>
       <p:nvGrpSpPr>
         <p:cNvPr id="1" name=""/>
@@ -1870,7 +1654,7 @@
           </a:prstGeom>
           <a:extLst>
             <a:ext uri="{C572A759-6A51-4108-AA02-DFA0A04FC94B}">
-              <ma14:wrappingTextBoxFlag xmlns:ma14="http://schemas.microsoft.com/office/mac/drawingml/2011/main" val="0"/>
+              <ma14:wrappingTextBoxFlag xmlns:ma14="http://schemas.microsoft.com/office/mac/drawingml/2011/main" xmlns="" val="0"/>
             </a:ext>
           </a:extLst>
         </p:spPr>
@@ -1888,8 +1672,8 @@
           <a:p>
             <a:pPr algn="r"/>
             <a:fld id="{F7021451-1387-4CA6-816F-3879F97B5CBC}" type="slidenum">
-              <a:rPr b="0" lang="en-US"/>
-              <a:t>null</a:t>
+              <a:rPr lang="en-US" b="0"/>
+              <a:t>‹#›</a:t>
             </a:fld>
             <a:endParaRPr lang="en-US"/>
           </a:p>
@@ -2177,9 +1961,11 @@
       <p:sp>
         <p:nvSpPr>
           <p:cNvPr id="2" name="Text 0"/>
-          <p:cNvSpPr/>
+          <p:cNvSpPr>
+            <a:spLocks noGrp="1"/>
+          </p:cNvSpPr>
           <p:nvPr>
-            <p:ph idx="100" type="title" hasCustomPrompt="1"/>
+            <p:ph type="title" idx="100" hasCustomPrompt="1"/>
           </p:nvPr>
         </p:nvSpPr>
         <p:spPr>
@@ -2197,7 +1983,7 @@
           <a:bodyPr wrap="square" lIns="0" tIns="0" rIns="0" bIns="0" rtlCol="0" anchor="b"/>
           <a:lstStyle/>
           <a:p>
-            <a:pPr algn="l" indent="0" marL="0">
+            <a:pPr marL="0" indent="0" algn="l">
               <a:buNone/>
             </a:pPr>
             <a:r>
@@ -2215,9 +2001,11 @@
       <p:sp>
         <p:nvSpPr>
           <p:cNvPr id="3" name="Text 0"/>
-          <p:cNvSpPr/>
+          <p:cNvSpPr>
+            <a:spLocks noGrp="1"/>
+          </p:cNvSpPr>
           <p:nvPr>
-            <p:ph idx="101" type="body" hasCustomPrompt="1"/>
+            <p:ph type="body" idx="101" hasCustomPrompt="1"/>
           </p:nvPr>
         </p:nvSpPr>
         <p:spPr>
@@ -2235,7 +2023,7 @@
           <a:bodyPr wrap="square" lIns="0" tIns="0" rIns="0" bIns="0" rtlCol="0" anchor="t"/>
           <a:lstStyle/>
           <a:p>
-            <a:pPr algn="l" indent="0" marL="0">
+            <a:pPr marL="0" indent="0" algn="l">
               <a:buNone/>
             </a:pPr>
             <a:r>
@@ -2249,7 +2037,7 @@
             <a:endParaRPr lang="en-US" sz="2000" dirty="0"/>
           </a:p>
           <a:p>
-            <a:pPr algn="l" indent="0" marL="0">
+            <a:pPr marL="0" indent="0" algn="l">
               <a:buNone/>
             </a:pPr>
             <a:r>
@@ -2267,9 +2055,11 @@
       <p:sp>
         <p:nvSpPr>
           <p:cNvPr id="4" name="Text 0"/>
-          <p:cNvSpPr/>
+          <p:cNvSpPr>
+            <a:spLocks noGrp="1"/>
+          </p:cNvSpPr>
           <p:nvPr>
-            <p:ph idx="102" type="body" hasCustomPrompt="1"/>
+            <p:ph type="body" idx="102" hasCustomPrompt="1"/>
           </p:nvPr>
         </p:nvSpPr>
         <p:spPr>
@@ -2287,7 +2077,7 @@
           <a:bodyPr wrap="square" lIns="0" tIns="0" rIns="0" bIns="0" rtlCol="0" anchor="t"/>
           <a:lstStyle/>
           <a:p>
-            <a:pPr algn="l" indent="0" marL="0">
+            <a:pPr marL="0" indent="0" algn="l">
               <a:buNone/>
             </a:pPr>
             <a:r>
@@ -2301,7 +2091,7 @@
             <a:endParaRPr lang="en-US" sz="1400" dirty="0"/>
           </a:p>
           <a:p>
-            <a:pPr algn="l" indent="0" marL="0">
+            <a:pPr marL="0" indent="0" algn="l">
               <a:buNone/>
             </a:pPr>
             <a:r>
@@ -2315,7 +2105,7 @@
             <a:endParaRPr lang="en-US" sz="1400" dirty="0"/>
           </a:p>
           <a:p>
-            <a:pPr algn="l" indent="0" marL="0">
+            <a:pPr marL="0" indent="0" algn="l">
               <a:buNone/>
             </a:pPr>
             <a:r>
@@ -2349,98 +2139,17 @@
           </a:solidFill>
           <a:ln/>
         </p:spPr>
+        <p:txBody>
+          <a:bodyPr/>
+          <a:lstStyle/>
+          <a:p>
+            <a:endParaRPr lang="en-US"/>
+          </a:p>
+        </p:txBody>
       </p:sp>
       <p:pic>
         <p:nvPicPr>
-          <p:cNvPr id="6" name="cover-dog-1" descr="Foto de perro del dataset DogFaceNet">    </p:cNvPr>
-          <p:cNvPicPr>
-            <a:picLocks noChangeAspect="1"/>
-          </p:cNvPicPr>
-          <p:nvPr/>
-        </p:nvPicPr>
-        <p:blipFill>
-          <a:blip r:embed="rId1"/>
-          <a:stretch>
-            <a:fillRect/>
-          </a:stretch>
-        </p:blipFill>
-        <p:spPr>
-          <a:xfrm>
-            <a:off x="7635240" y="1143000"/>
-            <a:ext cx="1874520" cy="1874520"/>
-          </a:xfrm>
-          <a:prstGeom prst="ellipse">
-            <a:avLst/>
-          </a:prstGeom>
-        </p:spPr>
-      </p:pic>
-      <p:sp>
-        <p:nvSpPr>
-          <p:cNvPr id="7" name="cover-ring-2"/>
-          <p:cNvSpPr/>
-          <p:nvPr/>
-        </p:nvSpPr>
-        <p:spPr>
-          <a:xfrm>
-            <a:off x="9729216" y="1088136"/>
-            <a:ext cx="1984248" cy="1984248"/>
-          </a:xfrm>
-          <a:prstGeom prst="ellipse">
-            <a:avLst/>
-          </a:prstGeom>
-          <a:solidFill>
-            <a:srgbClr val="E8963B"/>
-          </a:solidFill>
-          <a:ln/>
-        </p:spPr>
-      </p:sp>
-      <p:pic>
-        <p:nvPicPr>
-          <p:cNvPr id="8" name="cover-dog-2" descr="Foto de perro del dataset DogFaceNet">    </p:cNvPr>
-          <p:cNvPicPr>
-            <a:picLocks noChangeAspect="1"/>
-          </p:cNvPicPr>
-          <p:nvPr/>
-        </p:nvPicPr>
-        <p:blipFill>
-          <a:blip r:embed="rId2"/>
-          <a:stretch>
-            <a:fillRect/>
-          </a:stretch>
-        </p:blipFill>
-        <p:spPr>
-          <a:xfrm>
-            <a:off x="9784080" y="1143000"/>
-            <a:ext cx="1874520" cy="1874520"/>
-          </a:xfrm>
-          <a:prstGeom prst="ellipse">
-            <a:avLst/>
-          </a:prstGeom>
-        </p:spPr>
-      </p:pic>
-      <p:sp>
-        <p:nvSpPr>
-          <p:cNvPr id="9" name="cover-ring-3"/>
-          <p:cNvSpPr/>
-          <p:nvPr/>
-        </p:nvSpPr>
-        <p:spPr>
-          <a:xfrm>
-            <a:off x="7580376" y="3236976"/>
-            <a:ext cx="1984248" cy="1984248"/>
-          </a:xfrm>
-          <a:prstGeom prst="ellipse">
-            <a:avLst/>
-          </a:prstGeom>
-          <a:solidFill>
-            <a:srgbClr val="E8963B"/>
-          </a:solidFill>
-          <a:ln/>
-        </p:spPr>
-      </p:sp>
-      <p:pic>
-        <p:nvPicPr>
-          <p:cNvPr id="10" name="cover-dog-3" descr="Foto de perro del dataset DogFaceNet">    </p:cNvPr>
+          <p:cNvPr id="6" name="cover-dog-1" descr="Foto de perro del dataset DogFaceNet"/>
           <p:cNvPicPr>
             <a:picLocks noChangeAspect="1"/>
           </p:cNvPicPr>
@@ -2454,7 +2163,7 @@
         </p:blipFill>
         <p:spPr>
           <a:xfrm>
-            <a:off x="7635240" y="3291840"/>
+            <a:off x="7635240" y="1143000"/>
             <a:ext cx="1874520" cy="1874520"/>
           </a:xfrm>
           <a:prstGeom prst="ellipse">
@@ -2464,13 +2173,13 @@
       </p:pic>
       <p:sp>
         <p:nvSpPr>
-          <p:cNvPr id="11" name="cover-ring-4"/>
+          <p:cNvPr id="7" name="cover-ring-2"/>
           <p:cNvSpPr/>
           <p:nvPr/>
         </p:nvSpPr>
         <p:spPr>
           <a:xfrm>
-            <a:off x="9729216" y="3236976"/>
+            <a:off x="9729216" y="1088136"/>
             <a:ext cx="1984248" cy="1984248"/>
           </a:xfrm>
           <a:prstGeom prst="ellipse">
@@ -2481,10 +2190,17 @@
           </a:solidFill>
           <a:ln/>
         </p:spPr>
+        <p:txBody>
+          <a:bodyPr/>
+          <a:lstStyle/>
+          <a:p>
+            <a:endParaRPr lang="en-US"/>
+          </a:p>
+        </p:txBody>
       </p:sp>
       <p:pic>
         <p:nvPicPr>
-          <p:cNvPr id="12" name="cover-dog-4" descr="Foto de perro del dataset DogFaceNet">    </p:cNvPr>
+          <p:cNvPr id="8" name="cover-dog-2" descr="Foto de perro del dataset DogFaceNet"/>
           <p:cNvPicPr>
             <a:picLocks noChangeAspect="1"/>
           </p:cNvPicPr>
@@ -2498,6 +2214,108 @@
         </p:blipFill>
         <p:spPr>
           <a:xfrm>
+            <a:off x="9784080" y="1143000"/>
+            <a:ext cx="1874520" cy="1874520"/>
+          </a:xfrm>
+          <a:prstGeom prst="ellipse">
+            <a:avLst/>
+          </a:prstGeom>
+        </p:spPr>
+      </p:pic>
+      <p:sp>
+        <p:nvSpPr>
+          <p:cNvPr id="9" name="cover-ring-3"/>
+          <p:cNvSpPr/>
+          <p:nvPr/>
+        </p:nvSpPr>
+        <p:spPr>
+          <a:xfrm>
+            <a:off x="7580376" y="3236976"/>
+            <a:ext cx="1984248" cy="1984248"/>
+          </a:xfrm>
+          <a:prstGeom prst="ellipse">
+            <a:avLst/>
+          </a:prstGeom>
+          <a:solidFill>
+            <a:srgbClr val="E8963B"/>
+          </a:solidFill>
+          <a:ln/>
+        </p:spPr>
+        <p:txBody>
+          <a:bodyPr/>
+          <a:lstStyle/>
+          <a:p>
+            <a:endParaRPr lang="en-US"/>
+          </a:p>
+        </p:txBody>
+      </p:sp>
+      <p:pic>
+        <p:nvPicPr>
+          <p:cNvPr id="10" name="cover-dog-3" descr="Foto de perro del dataset DogFaceNet"/>
+          <p:cNvPicPr>
+            <a:picLocks noChangeAspect="1"/>
+          </p:cNvPicPr>
+          <p:nvPr/>
+        </p:nvPicPr>
+        <p:blipFill>
+          <a:blip r:embed="rId5"/>
+          <a:stretch>
+            <a:fillRect/>
+          </a:stretch>
+        </p:blipFill>
+        <p:spPr>
+          <a:xfrm>
+            <a:off x="7635240" y="3291840"/>
+            <a:ext cx="1874520" cy="1874520"/>
+          </a:xfrm>
+          <a:prstGeom prst="ellipse">
+            <a:avLst/>
+          </a:prstGeom>
+        </p:spPr>
+      </p:pic>
+      <p:sp>
+        <p:nvSpPr>
+          <p:cNvPr id="11" name="cover-ring-4"/>
+          <p:cNvSpPr/>
+          <p:nvPr/>
+        </p:nvSpPr>
+        <p:spPr>
+          <a:xfrm>
+            <a:off x="9729216" y="3236976"/>
+            <a:ext cx="1984248" cy="1984248"/>
+          </a:xfrm>
+          <a:prstGeom prst="ellipse">
+            <a:avLst/>
+          </a:prstGeom>
+          <a:solidFill>
+            <a:srgbClr val="E8963B"/>
+          </a:solidFill>
+          <a:ln/>
+        </p:spPr>
+        <p:txBody>
+          <a:bodyPr/>
+          <a:lstStyle/>
+          <a:p>
+            <a:endParaRPr lang="en-US"/>
+          </a:p>
+        </p:txBody>
+      </p:sp>
+      <p:pic>
+        <p:nvPicPr>
+          <p:cNvPr id="12" name="cover-dog-4" descr="Foto de perro del dataset DogFaceNet"/>
+          <p:cNvPicPr>
+            <a:picLocks noChangeAspect="1"/>
+          </p:cNvPicPr>
+          <p:nvPr/>
+        </p:nvPicPr>
+        <p:blipFill>
+          <a:blip r:embed="rId6"/>
+          <a:stretch>
+            <a:fillRect/>
+          </a:stretch>
+        </p:blipFill>
+        <p:spPr>
+          <a:xfrm>
             <a:off x="9784080" y="3291840"/>
             <a:ext cx="1874520" cy="1874520"/>
           </a:xfrm>
@@ -2527,7 +2345,7 @@
           <a:bodyPr wrap="square" lIns="0" tIns="0" rIns="0" bIns="0" rtlCol="0" anchor="ctr"/>
           <a:lstStyle/>
           <a:p>
-            <a:pPr indent="0" marL="0">
+            <a:pPr marL="0" indent="0">
               <a:buNone/>
             </a:pPr>
             <a:r>
@@ -2570,9 +2388,11 @@
       <p:sp>
         <p:nvSpPr>
           <p:cNvPr id="2" name="Text 0"/>
-          <p:cNvSpPr/>
+          <p:cNvSpPr>
+            <a:spLocks noGrp="1"/>
+          </p:cNvSpPr>
           <p:nvPr>
-            <p:ph idx="100" type="title" hasCustomPrompt="1"/>
+            <p:ph type="title" idx="100" hasCustomPrompt="1"/>
           </p:nvPr>
         </p:nvSpPr>
         <p:spPr>
@@ -2590,7 +2410,7 @@
           <a:bodyPr wrap="square" lIns="0" tIns="0" rIns="0" bIns="0" rtlCol="0" anchor="ctr"/>
           <a:lstStyle/>
           <a:p>
-            <a:pPr indent="0" marL="0">
+            <a:pPr marL="0" indent="0">
               <a:buNone/>
             </a:pPr>
             <a:r>
@@ -2626,7 +2446,7 @@
           <a:bodyPr wrap="square" lIns="0" tIns="0" rIns="0" bIns="0" rtlCol="0" anchor="ctr"/>
           <a:lstStyle/>
           <a:p>
-            <a:pPr indent="0" marL="0">
+            <a:pPr marL="0" indent="0">
               <a:buNone/>
             </a:pPr>
             <a:r>
@@ -2662,6 +2482,13 @@
           </a:solidFill>
           <a:ln/>
         </p:spPr>
+        <p:txBody>
+          <a:bodyPr/>
+          <a:lstStyle/>
+          <a:p>
+            <a:endParaRPr lang="en-US"/>
+          </a:p>
+        </p:txBody>
       </p:sp>
       <p:sp>
         <p:nvSpPr>
@@ -2684,7 +2511,7 @@
           <a:bodyPr wrap="square" lIns="0" tIns="0" rIns="0" bIns="0" rtlCol="0" anchor="t"/>
           <a:lstStyle/>
           <a:p>
-            <a:pPr indent="0" marL="0">
+            <a:pPr marL="0" indent="0">
               <a:spcAft>
                 <a:spcPts val="300"/>
               </a:spcAft>
@@ -2701,7 +2528,7 @@
             <a:endParaRPr lang="en-US" sz="1500" dirty="0"/>
           </a:p>
           <a:p>
-            <a:pPr indent="0" marL="0">
+            <a:pPr marL="0" indent="0">
               <a:spcAft>
                 <a:spcPts val="300"/>
               </a:spcAft>
@@ -2742,6 +2569,13 @@
             <a:tailEnd type="triangle"/>
           </a:ln>
         </p:spPr>
+        <p:txBody>
+          <a:bodyPr/>
+          <a:lstStyle/>
+          <a:p>
+            <a:endParaRPr lang="en-US"/>
+          </a:p>
+        </p:txBody>
       </p:sp>
       <p:sp>
         <p:nvSpPr>
@@ -2764,6 +2598,13 @@
           </a:solidFill>
           <a:ln/>
         </p:spPr>
+        <p:txBody>
+          <a:bodyPr/>
+          <a:lstStyle/>
+          <a:p>
+            <a:endParaRPr lang="en-US"/>
+          </a:p>
+        </p:txBody>
       </p:sp>
       <p:sp>
         <p:nvSpPr>
@@ -2786,7 +2627,7 @@
           <a:bodyPr wrap="square" lIns="0" tIns="0" rIns="0" bIns="0" rtlCol="0" anchor="t"/>
           <a:lstStyle/>
           <a:p>
-            <a:pPr indent="0" marL="0">
+            <a:pPr marL="0" indent="0">
               <a:spcAft>
                 <a:spcPts val="300"/>
               </a:spcAft>
@@ -2803,7 +2644,7 @@
             <a:endParaRPr lang="en-US" sz="1500" dirty="0"/>
           </a:p>
           <a:p>
-            <a:pPr indent="0" marL="0">
+            <a:pPr marL="0" indent="0">
               <a:spcAft>
                 <a:spcPts val="300"/>
               </a:spcAft>
@@ -2844,6 +2685,13 @@
             <a:tailEnd type="triangle"/>
           </a:ln>
         </p:spPr>
+        <p:txBody>
+          <a:bodyPr/>
+          <a:lstStyle/>
+          <a:p>
+            <a:endParaRPr lang="en-US"/>
+          </a:p>
+        </p:txBody>
       </p:sp>
       <p:sp>
         <p:nvSpPr>
@@ -2871,6 +2719,13 @@
             <a:prstDash val="solid"/>
           </a:ln>
         </p:spPr>
+        <p:txBody>
+          <a:bodyPr/>
+          <a:lstStyle/>
+          <a:p>
+            <a:endParaRPr lang="en-US"/>
+          </a:p>
+        </p:txBody>
       </p:sp>
       <p:sp>
         <p:nvSpPr>
@@ -2893,7 +2748,7 @@
           <a:bodyPr wrap="square" lIns="0" tIns="0" rIns="0" bIns="0" rtlCol="0" anchor="t"/>
           <a:lstStyle/>
           <a:p>
-            <a:pPr indent="0" marL="0">
+            <a:pPr marL="0" indent="0">
               <a:spcAft>
                 <a:spcPts val="300"/>
               </a:spcAft>
@@ -2910,7 +2765,7 @@
             <a:endParaRPr lang="en-US" sz="1500" dirty="0"/>
           </a:p>
           <a:p>
-            <a:pPr indent="0" marL="0">
+            <a:pPr marL="0" indent="0">
               <a:spcAft>
                 <a:spcPts val="300"/>
               </a:spcAft>
@@ -2951,6 +2806,13 @@
             <a:tailEnd type="triangle"/>
           </a:ln>
         </p:spPr>
+        <p:txBody>
+          <a:bodyPr/>
+          <a:lstStyle/>
+          <a:p>
+            <a:endParaRPr lang="en-US"/>
+          </a:p>
+        </p:txBody>
       </p:sp>
       <p:sp>
         <p:nvSpPr>
@@ -2978,6 +2840,13 @@
             <a:prstDash val="solid"/>
           </a:ln>
         </p:spPr>
+        <p:txBody>
+          <a:bodyPr/>
+          <a:lstStyle/>
+          <a:p>
+            <a:endParaRPr lang="en-US"/>
+          </a:p>
+        </p:txBody>
       </p:sp>
       <p:sp>
         <p:nvSpPr>
@@ -3000,7 +2869,7 @@
           <a:bodyPr wrap="square" lIns="0" tIns="0" rIns="0" bIns="0" rtlCol="0" anchor="t"/>
           <a:lstStyle/>
           <a:p>
-            <a:pPr indent="0" marL="0">
+            <a:pPr marL="0" indent="0">
               <a:spcAft>
                 <a:spcPts val="300"/>
               </a:spcAft>
@@ -3017,7 +2886,7 @@
             <a:endParaRPr lang="en-US" sz="1500" dirty="0"/>
           </a:p>
           <a:p>
-            <a:pPr indent="0" marL="0">
+            <a:pPr marL="0" indent="0">
               <a:spcAft>
                 <a:spcPts val="300"/>
               </a:spcAft>
@@ -3058,6 +2927,13 @@
             <a:tailEnd type="triangle"/>
           </a:ln>
         </p:spPr>
+        <p:txBody>
+          <a:bodyPr/>
+          <a:lstStyle/>
+          <a:p>
+            <a:endParaRPr lang="en-US"/>
+          </a:p>
+        </p:txBody>
       </p:sp>
       <p:sp>
         <p:nvSpPr>
@@ -3080,6 +2956,13 @@
           </a:solidFill>
           <a:ln/>
         </p:spPr>
+        <p:txBody>
+          <a:bodyPr/>
+          <a:lstStyle/>
+          <a:p>
+            <a:endParaRPr lang="en-US"/>
+          </a:p>
+        </p:txBody>
       </p:sp>
       <p:sp>
         <p:nvSpPr>
@@ -3102,7 +2985,7 @@
           <a:bodyPr wrap="square" lIns="0" tIns="0" rIns="0" bIns="0" rtlCol="0" anchor="t"/>
           <a:lstStyle/>
           <a:p>
-            <a:pPr indent="0" marL="0">
+            <a:pPr marL="0" indent="0">
               <a:spcAft>
                 <a:spcPts val="300"/>
               </a:spcAft>
@@ -3119,7 +3002,7 @@
             <a:endParaRPr lang="en-US" sz="1500" dirty="0"/>
           </a:p>
           <a:p>
-            <a:pPr indent="0" marL="0">
+            <a:pPr marL="0" indent="0">
               <a:spcAft>
                 <a:spcPts val="300"/>
               </a:spcAft>
@@ -3158,7 +3041,7 @@
           <a:bodyPr wrap="square" lIns="0" tIns="0" rIns="0" bIns="0" rtlCol="0" anchor="ctr"/>
           <a:lstStyle/>
           <a:p>
-            <a:pPr indent="0" marL="0">
+            <a:pPr marL="0" indent="0">
               <a:buNone/>
             </a:pPr>
             <a:r>
@@ -3194,6 +3077,13 @@
           </a:solidFill>
           <a:ln/>
         </p:spPr>
+        <p:txBody>
+          <a:bodyPr/>
+          <a:lstStyle/>
+          <a:p>
+            <a:endParaRPr lang="en-US"/>
+          </a:p>
+        </p:txBody>
       </p:sp>
       <p:sp>
         <p:nvSpPr>
@@ -3216,7 +3106,7 @@
           <a:bodyPr wrap="square" lIns="0" tIns="0" rIns="0" bIns="0" rtlCol="0" anchor="t"/>
           <a:lstStyle/>
           <a:p>
-            <a:pPr indent="0" marL="0">
+            <a:pPr marL="0" indent="0">
               <a:spcAft>
                 <a:spcPts val="300"/>
               </a:spcAft>
@@ -3233,7 +3123,7 @@
             <a:endParaRPr lang="en-US" sz="1500" dirty="0"/>
           </a:p>
           <a:p>
-            <a:pPr indent="0" marL="0">
+            <a:pPr marL="0" indent="0">
               <a:spcAft>
                 <a:spcPts val="300"/>
               </a:spcAft>
@@ -3272,6 +3162,13 @@
           </a:solidFill>
           <a:ln/>
         </p:spPr>
+        <p:txBody>
+          <a:bodyPr/>
+          <a:lstStyle/>
+          <a:p>
+            <a:endParaRPr lang="en-US"/>
+          </a:p>
+        </p:txBody>
       </p:sp>
       <p:sp>
         <p:nvSpPr>
@@ -3294,7 +3191,7 @@
           <a:bodyPr wrap="square" lIns="0" tIns="0" rIns="0" bIns="0" rtlCol="0" anchor="t"/>
           <a:lstStyle/>
           <a:p>
-            <a:pPr indent="0" marL="0">
+            <a:pPr marL="0" indent="0">
               <a:spcAft>
                 <a:spcPts val="300"/>
               </a:spcAft>
@@ -3311,7 +3208,7 @@
             <a:endParaRPr lang="en-US" sz="1500" dirty="0"/>
           </a:p>
           <a:p>
-            <a:pPr indent="0" marL="0">
+            <a:pPr marL="0" indent="0">
               <a:spcAft>
                 <a:spcPts val="300"/>
               </a:spcAft>
@@ -3355,6 +3252,13 @@
             <a:prstDash val="solid"/>
           </a:ln>
         </p:spPr>
+        <p:txBody>
+          <a:bodyPr/>
+          <a:lstStyle/>
+          <a:p>
+            <a:endParaRPr lang="en-US"/>
+          </a:p>
+        </p:txBody>
       </p:sp>
       <p:sp>
         <p:nvSpPr>
@@ -3377,7 +3281,7 @@
           <a:bodyPr wrap="square" lIns="0" tIns="0" rIns="0" bIns="0" rtlCol="0" anchor="t"/>
           <a:lstStyle/>
           <a:p>
-            <a:pPr indent="0" marL="0">
+            <a:pPr marL="0" indent="0">
               <a:spcAft>
                 <a:spcPts val="300"/>
               </a:spcAft>
@@ -3394,7 +3298,7 @@
             <a:endParaRPr lang="en-US" sz="1500" dirty="0"/>
           </a:p>
           <a:p>
-            <a:pPr indent="0" marL="0">
+            <a:pPr marL="0" indent="0">
               <a:spcAft>
                 <a:spcPts val="300"/>
               </a:spcAft>
@@ -3433,6 +3337,13 @@
           </a:solidFill>
           <a:ln/>
         </p:spPr>
+        <p:txBody>
+          <a:bodyPr/>
+          <a:lstStyle/>
+          <a:p>
+            <a:endParaRPr lang="en-US"/>
+          </a:p>
+        </p:txBody>
       </p:sp>
       <p:sp>
         <p:nvSpPr>
@@ -3455,7 +3366,7 @@
           <a:bodyPr wrap="square" lIns="0" tIns="0" rIns="0" bIns="0" rtlCol="0" anchor="t"/>
           <a:lstStyle/>
           <a:p>
-            <a:pPr indent="0" marL="0">
+            <a:pPr marL="0" indent="0">
               <a:spcAft>
                 <a:spcPts val="300"/>
               </a:spcAft>
@@ -3472,7 +3383,7 @@
             <a:endParaRPr lang="en-US" sz="1500" dirty="0"/>
           </a:p>
           <a:p>
-            <a:pPr indent="0" marL="0">
+            <a:pPr marL="0" indent="0">
               <a:spcAft>
                 <a:spcPts val="300"/>
               </a:spcAft>
@@ -3513,6 +3424,13 @@
             <a:tailEnd type="triangle"/>
           </a:ln>
         </p:spPr>
+        <p:txBody>
+          <a:bodyPr/>
+          <a:lstStyle/>
+          <a:p>
+            <a:endParaRPr lang="en-US"/>
+          </a:p>
+        </p:txBody>
       </p:sp>
       <p:sp>
         <p:nvSpPr>
@@ -3537,6 +3455,13 @@
             <a:tailEnd type="triangle"/>
           </a:ln>
         </p:spPr>
+        <p:txBody>
+          <a:bodyPr/>
+          <a:lstStyle/>
+          <a:p>
+            <a:endParaRPr lang="en-US"/>
+          </a:p>
+        </p:txBody>
       </p:sp>
       <p:sp>
         <p:nvSpPr>
@@ -3561,6 +3486,13 @@
             <a:tailEnd type="triangle"/>
           </a:ln>
         </p:spPr>
+        <p:txBody>
+          <a:bodyPr/>
+          <a:lstStyle/>
+          <a:p>
+            <a:endParaRPr lang="en-US"/>
+          </a:p>
+        </p:txBody>
       </p:sp>
       <p:sp>
         <p:nvSpPr>
@@ -3585,6 +3517,13 @@
             <a:tailEnd type="triangle"/>
           </a:ln>
         </p:spPr>
+        <p:txBody>
+          <a:bodyPr/>
+          <a:lstStyle/>
+          <a:p>
+            <a:endParaRPr lang="en-US"/>
+          </a:p>
+        </p:txBody>
       </p:sp>
       <p:sp>
         <p:nvSpPr>
@@ -3609,6 +3548,13 @@
             <a:tailEnd type="triangle"/>
           </a:ln>
         </p:spPr>
+        <p:txBody>
+          <a:bodyPr/>
+          <a:lstStyle/>
+          <a:p>
+            <a:endParaRPr lang="en-US"/>
+          </a:p>
+        </p:txBody>
       </p:sp>
       <p:sp>
         <p:nvSpPr>
@@ -3633,6 +3579,13 @@
             <a:tailEnd type="triangle"/>
           </a:ln>
         </p:spPr>
+        <p:txBody>
+          <a:bodyPr/>
+          <a:lstStyle/>
+          <a:p>
+            <a:endParaRPr lang="en-US"/>
+          </a:p>
+        </p:txBody>
       </p:sp>
       <p:sp>
         <p:nvSpPr>
@@ -3655,7 +3608,7 @@
           <a:bodyPr wrap="square" lIns="0" tIns="0" rIns="0" bIns="0" rtlCol="0" anchor="ctr"/>
           <a:lstStyle/>
           <a:p>
-            <a:pPr indent="0" marL="0">
+            <a:pPr marL="0" indent="0">
               <a:buNone/>
             </a:pPr>
             <a:r>
@@ -3696,6 +3649,13 @@
             <a:prstDash val="solid"/>
           </a:ln>
         </p:spPr>
+        <p:txBody>
+          <a:bodyPr/>
+          <a:lstStyle/>
+          <a:p>
+            <a:endParaRPr lang="en-US"/>
+          </a:p>
+        </p:txBody>
       </p:sp>
       <p:sp>
         <p:nvSpPr>
@@ -3718,7 +3678,7 @@
           <a:bodyPr wrap="square" lIns="0" tIns="0" rIns="0" bIns="0" rtlCol="0" anchor="ctr"/>
           <a:lstStyle/>
           <a:p>
-            <a:pPr indent="0" marL="0">
+            <a:pPr marL="0" indent="0">
               <a:buNone/>
             </a:pPr>
             <a:r>
@@ -3754,6 +3714,13 @@
           </a:solidFill>
           <a:ln/>
         </p:spPr>
+        <p:txBody>
+          <a:bodyPr/>
+          <a:lstStyle/>
+          <a:p>
+            <a:endParaRPr lang="en-US"/>
+          </a:p>
+        </p:txBody>
       </p:sp>
       <p:sp>
         <p:nvSpPr>
@@ -3776,7 +3743,7 @@
           <a:bodyPr wrap="square" lIns="0" tIns="0" rIns="0" bIns="0" rtlCol="0" anchor="ctr"/>
           <a:lstStyle/>
           <a:p>
-            <a:pPr indent="0" marL="0">
+            <a:pPr marL="0" indent="0">
               <a:buNone/>
             </a:pPr>
             <a:r>
@@ -3812,7 +3779,7 @@
           <a:bodyPr wrap="square" lIns="0" tIns="0" rIns="0" bIns="0" rtlCol="0" anchor="ctr"/>
           <a:lstStyle/>
           <a:p>
-            <a:pPr indent="0" marL="0">
+            <a:pPr marL="0" indent="0">
               <a:buNone/>
             </a:pPr>
             <a:r>
@@ -3823,9 +3790,6 @@
               </a:rPr>
               <a:t>Distancia: </a:t>
             </a:r>
-            <a:pPr indent="0" marL="0">
-              <a:buNone/>
-            </a:pPr>
             <a:r>
               <a:rPr lang="en-US" sz="1200" dirty="0">
                 <a:solidFill>
@@ -3834,9 +3798,6 @@
               </a:rPr>
               <a:t>qué tan distintas son dos fotos (menor = más parecidas; no es un porcentaje).   </a:t>
             </a:r>
-            <a:pPr indent="0" marL="0">
-              <a:buNone/>
-            </a:pPr>
             <a:r>
               <a:rPr lang="en-US" sz="1200" b="1" dirty="0">
                 <a:solidFill>
@@ -3845,9 +3806,6 @@
               </a:rPr>
               <a:t>Umbral: </a:t>
             </a:r>
-            <a:pPr indent="0" marL="0">
-              <a:buNone/>
-            </a:pPr>
             <a:r>
               <a:rPr lang="en-US" sz="1200" dirty="0">
                 <a:solidFill>
@@ -3862,7 +3820,7 @@
       </p:sp>
       <p:sp>
         <p:nvSpPr>
-          <p:cNvPr id="25" name="Slide Number Placeholder 0"/>
+          <p:cNvPr id="39" name="Slide Number Placeholder 0"/>
           <p:cNvSpPr>
             <a:spLocks noGrp="1"/>
           </p:cNvSpPr>
@@ -3880,7 +3838,7 @@
           </a:prstGeom>
           <a:extLst>
             <a:ext uri="{C572A759-6A51-4108-AA02-DFA0A04FC94B}">
-              <ma14:wrappingTextBoxFlag xmlns:ma14="http://schemas.microsoft.com/office/mac/drawingml/2011/main" val="0"/>
+              <ma14:wrappingTextBoxFlag xmlns:ma14="http://schemas.microsoft.com/office/mac/drawingml/2011/main" xmlns="" val="0"/>
             </a:ext>
           </a:extLst>
         </p:spPr>
@@ -3898,7 +3856,7 @@
           <a:p>
             <a:pPr algn="r"/>
             <a:fld id="{F7021451-1387-4CA6-816F-3879F97B5CBC}" type="slidenum">
-              <a:rPr b="0" lang="en-US"/>
+              <a:rPr lang="en-US" b="0"/>
               <a:t>2</a:t>
             </a:fld>
             <a:endParaRPr lang="en-US"/>
@@ -3933,9 +3891,11 @@
       <p:sp>
         <p:nvSpPr>
           <p:cNvPr id="2" name="Text 0"/>
-          <p:cNvSpPr/>
+          <p:cNvSpPr>
+            <a:spLocks noGrp="1"/>
+          </p:cNvSpPr>
           <p:nvPr>
-            <p:ph idx="100" type="title" hasCustomPrompt="1"/>
+            <p:ph type="title" idx="100" hasCustomPrompt="1"/>
           </p:nvPr>
         </p:nvSpPr>
         <p:spPr>
@@ -3953,7 +3913,7 @@
           <a:bodyPr wrap="square" lIns="0" tIns="0" rIns="0" bIns="0" rtlCol="0" anchor="ctr"/>
           <a:lstStyle/>
           <a:p>
-            <a:pPr indent="0" marL="0">
+            <a:pPr marL="0" indent="0">
               <a:buNone/>
             </a:pPr>
             <a:r>
@@ -3970,7 +3930,7 @@
       </p:sp>
       <p:graphicFrame>
         <p:nvGraphicFramePr>
-          <p:cNvPr id="3" name="top1-chart" descr=""/>
+          <p:cNvPr id="3" name="top1-chart"/>
           <p:cNvGraphicFramePr/>
           <p:nvPr/>
         </p:nvGraphicFramePr>
@@ -3978,9 +3938,9 @@
           <a:off x="548640" y="1280160"/>
           <a:ext cx="6949440" cy="4846320"/>
         </p:xfrm>
-        <a:graphic xmlns:a="http://schemas.openxmlformats.org/drawingml/2006/main">
+        <a:graphic>
           <a:graphicData uri="http://schemas.openxmlformats.org/drawingml/2006/chart">
-            <c:chart xmlns:c="http://schemas.openxmlformats.org/drawingml/2006/chart" r:id="rId1"/>
+            <c:chart xmlns:c="http://schemas.openxmlformats.org/drawingml/2006/chart" xmlns:r="http://schemas.openxmlformats.org/officeDocument/2006/relationships" r:id="rId3"/>
           </a:graphicData>
         </a:graphic>
       </p:graphicFrame>
@@ -4005,6 +3965,13 @@
           </a:solidFill>
           <a:ln/>
         </p:spPr>
+        <p:txBody>
+          <a:bodyPr/>
+          <a:lstStyle/>
+          <a:p>
+            <a:endParaRPr lang="en-US"/>
+          </a:p>
+        </p:txBody>
       </p:sp>
       <p:sp>
         <p:nvSpPr>
@@ -4027,7 +3994,7 @@
           <a:bodyPr wrap="square" lIns="0" tIns="0" rIns="0" bIns="0" rtlCol="0" anchor="ctr"/>
           <a:lstStyle/>
           <a:p>
-            <a:pPr indent="0" marL="0">
+            <a:pPr marL="0" indent="0">
               <a:buNone/>
             </a:pPr>
             <a:r>
@@ -4066,7 +4033,7 @@
           <a:bodyPr wrap="square" lIns="0" tIns="0" rIns="0" bIns="0" rtlCol="0" anchor="t"/>
           <a:lstStyle/>
           <a:p>
-            <a:pPr indent="0" marL="0">
+            <a:pPr marL="0" indent="0">
               <a:buNone/>
             </a:pPr>
             <a:r>
@@ -4102,6 +4069,13 @@
           </a:solidFill>
           <a:ln/>
         </p:spPr>
+        <p:txBody>
+          <a:bodyPr/>
+          <a:lstStyle/>
+          <a:p>
+            <a:endParaRPr lang="en-US"/>
+          </a:p>
+        </p:txBody>
       </p:sp>
       <p:sp>
         <p:nvSpPr>
@@ -4124,7 +4098,7 @@
           <a:bodyPr wrap="square" lIns="0" tIns="0" rIns="0" bIns="0" rtlCol="0" anchor="ctr"/>
           <a:lstStyle/>
           <a:p>
-            <a:pPr indent="0" marL="0">
+            <a:pPr marL="0" indent="0">
               <a:buNone/>
             </a:pPr>
             <a:r>
@@ -4163,7 +4137,7 @@
           <a:bodyPr wrap="square" lIns="0" tIns="0" rIns="0" bIns="0" rtlCol="0" anchor="t"/>
           <a:lstStyle/>
           <a:p>
-            <a:pPr indent="0" marL="0">
+            <a:pPr marL="0" indent="0">
               <a:buNone/>
             </a:pPr>
             <a:r>
@@ -4199,7 +4173,7 @@
           <a:bodyPr wrap="square" lIns="0" tIns="0" rIns="0" bIns="0" rtlCol="0" anchor="t"/>
           <a:lstStyle/>
           <a:p>
-            <a:pPr indent="0" marL="0">
+            <a:pPr marL="0" indent="0">
               <a:buNone/>
             </a:pPr>
             <a:r>
@@ -4210,9 +4184,6 @@
               </a:rPr>
               <a:t>Datos: </a:t>
             </a:r>
-            <a:pPr indent="0" marL="0">
-              <a:buNone/>
-            </a:pPr>
             <a:r>
               <a:rPr lang="en-US" sz="1300" dirty="0">
                 <a:solidFill>
@@ -4245,7 +4216,7 @@
           </a:prstGeom>
           <a:extLst>
             <a:ext uri="{C572A759-6A51-4108-AA02-DFA0A04FC94B}">
-              <ma14:wrappingTextBoxFlag xmlns:ma14="http://schemas.microsoft.com/office/mac/drawingml/2011/main" val="0"/>
+              <ma14:wrappingTextBoxFlag xmlns:ma14="http://schemas.microsoft.com/office/mac/drawingml/2011/main" xmlns="" val="0"/>
             </a:ext>
           </a:extLst>
         </p:spPr>
@@ -4263,7 +4234,7 @@
           <a:p>
             <a:pPr algn="r"/>
             <a:fld id="{F7021451-1387-4CA6-816F-3879F97B5CBC}" type="slidenum">
-              <a:rPr b="0" lang="en-US"/>
+              <a:rPr lang="en-US" b="0"/>
               <a:t>3</a:t>
             </a:fld>
             <a:endParaRPr lang="en-US"/>
@@ -4298,9 +4269,11 @@
       <p:sp>
         <p:nvSpPr>
           <p:cNvPr id="2" name="Text 0"/>
-          <p:cNvSpPr/>
+          <p:cNvSpPr>
+            <a:spLocks noGrp="1"/>
+          </p:cNvSpPr>
           <p:nvPr>
-            <p:ph idx="100" type="title" hasCustomPrompt="1"/>
+            <p:ph type="title" idx="100" hasCustomPrompt="1"/>
           </p:nvPr>
         </p:nvSpPr>
         <p:spPr>
@@ -4318,7 +4291,7 @@
           <a:bodyPr wrap="square" lIns="0" tIns="0" rIns="0" bIns="0" rtlCol="0" anchor="ctr"/>
           <a:lstStyle/>
           <a:p>
-            <a:pPr indent="0" marL="0">
+            <a:pPr marL="0" indent="0">
               <a:buNone/>
             </a:pPr>
             <a:r>
@@ -4354,6 +4327,13 @@
           </a:solidFill>
           <a:ln/>
         </p:spPr>
+        <p:txBody>
+          <a:bodyPr/>
+          <a:lstStyle/>
+          <a:p>
+            <a:endParaRPr lang="en-US"/>
+          </a:p>
+        </p:txBody>
       </p:sp>
       <p:sp>
         <p:nvSpPr>
@@ -4376,7 +4356,7 @@
           <a:bodyPr wrap="square" lIns="0" tIns="0" rIns="0" bIns="0" rtlCol="0" anchor="ctr"/>
           <a:lstStyle/>
           <a:p>
-            <a:pPr indent="0" marL="0">
+            <a:pPr marL="0" indent="0">
               <a:buNone/>
             </a:pPr>
             <a:r>
@@ -4413,6 +4393,13 @@
           </a:solidFill>
           <a:ln/>
         </p:spPr>
+        <p:txBody>
+          <a:bodyPr/>
+          <a:lstStyle/>
+          <a:p>
+            <a:endParaRPr lang="en-US"/>
+          </a:p>
+        </p:txBody>
       </p:sp>
       <p:sp>
         <p:nvSpPr>
@@ -4435,7 +4422,7 @@
           <a:bodyPr wrap="square" lIns="0" tIns="0" rIns="0" bIns="0" rtlCol="0" anchor="ctr"/>
           <a:lstStyle/>
           <a:p>
-            <a:pPr algn="ctr" indent="0" marL="0">
+            <a:pPr marL="0" indent="0" algn="ctr">
               <a:buNone/>
             </a:pPr>
             <a:r>
@@ -4471,7 +4458,7 @@
           <a:bodyPr wrap="square" lIns="0" tIns="0" rIns="0" bIns="0" rtlCol="0" anchor="ctr"/>
           <a:lstStyle/>
           <a:p>
-            <a:pPr indent="0" marL="0">
+            <a:pPr marL="0" indent="0">
               <a:buNone/>
             </a:pPr>
             <a:r>
@@ -4505,6 +4492,13 @@
           </a:solidFill>
           <a:ln/>
         </p:spPr>
+        <p:txBody>
+          <a:bodyPr/>
+          <a:lstStyle/>
+          <a:p>
+            <a:endParaRPr lang="en-US"/>
+          </a:p>
+        </p:txBody>
       </p:sp>
       <p:sp>
         <p:nvSpPr>
@@ -4527,7 +4521,7 @@
           <a:bodyPr wrap="square" lIns="0" tIns="0" rIns="0" bIns="0" rtlCol="0" anchor="ctr"/>
           <a:lstStyle/>
           <a:p>
-            <a:pPr algn="ctr" indent="0" marL="0">
+            <a:pPr marL="0" indent="0" algn="ctr">
               <a:buNone/>
             </a:pPr>
             <a:r>
@@ -4563,7 +4557,7 @@
           <a:bodyPr wrap="square" lIns="0" tIns="0" rIns="0" bIns="0" rtlCol="0" anchor="ctr"/>
           <a:lstStyle/>
           <a:p>
-            <a:pPr indent="0" marL="0">
+            <a:pPr marL="0" indent="0">
               <a:buNone/>
             </a:pPr>
             <a:r>
@@ -4597,6 +4591,13 @@
           </a:solidFill>
           <a:ln/>
         </p:spPr>
+        <p:txBody>
+          <a:bodyPr/>
+          <a:lstStyle/>
+          <a:p>
+            <a:endParaRPr lang="en-US"/>
+          </a:p>
+        </p:txBody>
       </p:sp>
       <p:sp>
         <p:nvSpPr>
@@ -4619,7 +4620,7 @@
           <a:bodyPr wrap="square" lIns="0" tIns="0" rIns="0" bIns="0" rtlCol="0" anchor="ctr"/>
           <a:lstStyle/>
           <a:p>
-            <a:pPr algn="ctr" indent="0" marL="0">
+            <a:pPr marL="0" indent="0" algn="ctr">
               <a:buNone/>
             </a:pPr>
             <a:r>
@@ -4655,7 +4656,7 @@
           <a:bodyPr wrap="square" lIns="0" tIns="0" rIns="0" bIns="0" rtlCol="0" anchor="ctr"/>
           <a:lstStyle/>
           <a:p>
-            <a:pPr indent="0" marL="0">
+            <a:pPr marL="0" indent="0">
               <a:buNone/>
             </a:pPr>
             <a:r>
@@ -4691,6 +4692,13 @@
           </a:solidFill>
           <a:ln/>
         </p:spPr>
+        <p:txBody>
+          <a:bodyPr/>
+          <a:lstStyle/>
+          <a:p>
+            <a:endParaRPr lang="en-US"/>
+          </a:p>
+        </p:txBody>
       </p:sp>
       <p:sp>
         <p:nvSpPr>
@@ -4713,7 +4721,7 @@
           <a:bodyPr wrap="square" lIns="0" tIns="0" rIns="0" bIns="0" rtlCol="0" anchor="ctr"/>
           <a:lstStyle/>
           <a:p>
-            <a:pPr indent="0" marL="0">
+            <a:pPr marL="0" indent="0">
               <a:buNone/>
             </a:pPr>
             <a:r>
@@ -4750,6 +4758,13 @@
           </a:solidFill>
           <a:ln/>
         </p:spPr>
+        <p:txBody>
+          <a:bodyPr/>
+          <a:lstStyle/>
+          <a:p>
+            <a:endParaRPr lang="en-US"/>
+          </a:p>
+        </p:txBody>
       </p:sp>
       <p:sp>
         <p:nvSpPr>
@@ -4772,7 +4787,7 @@
           <a:bodyPr wrap="square" lIns="0" tIns="0" rIns="0" bIns="0" rtlCol="0" anchor="ctr"/>
           <a:lstStyle/>
           <a:p>
-            <a:pPr algn="ctr" indent="0" marL="0">
+            <a:pPr marL="0" indent="0" algn="ctr">
               <a:buNone/>
             </a:pPr>
             <a:r>
@@ -4808,7 +4823,7 @@
           <a:bodyPr wrap="square" lIns="0" tIns="0" rIns="0" bIns="0" rtlCol="0" anchor="ctr"/>
           <a:lstStyle/>
           <a:p>
-            <a:pPr indent="0" marL="0">
+            <a:pPr marL="0" indent="0">
               <a:buNone/>
             </a:pPr>
             <a:r>
@@ -4842,6 +4857,13 @@
           </a:solidFill>
           <a:ln/>
         </p:spPr>
+        <p:txBody>
+          <a:bodyPr/>
+          <a:lstStyle/>
+          <a:p>
+            <a:endParaRPr lang="en-US"/>
+          </a:p>
+        </p:txBody>
       </p:sp>
       <p:sp>
         <p:nvSpPr>
@@ -4864,7 +4886,7 @@
           <a:bodyPr wrap="square" lIns="0" tIns="0" rIns="0" bIns="0" rtlCol="0" anchor="ctr"/>
           <a:lstStyle/>
           <a:p>
-            <a:pPr algn="ctr" indent="0" marL="0">
+            <a:pPr marL="0" indent="0" algn="ctr">
               <a:buNone/>
             </a:pPr>
             <a:r>
@@ -4900,7 +4922,7 @@
           <a:bodyPr wrap="square" lIns="0" tIns="0" rIns="0" bIns="0" rtlCol="0" anchor="ctr"/>
           <a:lstStyle/>
           <a:p>
-            <a:pPr indent="0" marL="0">
+            <a:pPr marL="0" indent="0">
               <a:buNone/>
             </a:pPr>
             <a:r>
@@ -4934,6 +4956,13 @@
           </a:solidFill>
           <a:ln/>
         </p:spPr>
+        <p:txBody>
+          <a:bodyPr/>
+          <a:lstStyle/>
+          <a:p>
+            <a:endParaRPr lang="en-US"/>
+          </a:p>
+        </p:txBody>
       </p:sp>
       <p:sp>
         <p:nvSpPr>
@@ -4956,7 +4985,7 @@
           <a:bodyPr wrap="square" lIns="0" tIns="0" rIns="0" bIns="0" rtlCol="0" anchor="ctr"/>
           <a:lstStyle/>
           <a:p>
-            <a:pPr algn="ctr" indent="0" marL="0">
+            <a:pPr marL="0" indent="0" algn="ctr">
               <a:buNone/>
             </a:pPr>
             <a:r>
@@ -4992,7 +5021,7 @@
           <a:bodyPr wrap="square" lIns="0" tIns="0" rIns="0" bIns="0" rtlCol="0" anchor="ctr"/>
           <a:lstStyle/>
           <a:p>
-            <a:pPr indent="0" marL="0">
+            <a:pPr marL="0" indent="0">
               <a:buNone/>
             </a:pPr>
             <a:r>
@@ -5028,7 +5057,7 @@
           <a:bodyPr wrap="square" lIns="0" tIns="0" rIns="0" bIns="0" rtlCol="0" anchor="ctr"/>
           <a:lstStyle/>
           <a:p>
-            <a:pPr indent="0" marL="0">
+            <a:pPr marL="0" indent="0">
               <a:buNone/>
             </a:pPr>
             <a:r>
@@ -5042,9 +5071,6 @@
               </a:rPr>
               <a:t>83,2 %</a:t>
             </a:r>
-            <a:pPr indent="0" marL="0">
-              <a:buNone/>
-            </a:pPr>
             <a:r>
               <a:rPr lang="en-US" sz="1500" dirty="0">
                 <a:solidFill>
@@ -5053,9 +5079,6 @@
               </a:rPr>
               <a:t>  Top-1     </a:t>
             </a:r>
-            <a:pPr indent="0" marL="0">
-              <a:buNone/>
-            </a:pPr>
             <a:r>
               <a:rPr lang="en-US" sz="3600" b="1" dirty="0">
                 <a:solidFill>
@@ -5067,9 +5090,6 @@
               </a:rPr>
               <a:t>93,0 %</a:t>
             </a:r>
-            <a:pPr indent="0" marL="0">
-              <a:buNone/>
-            </a:pPr>
             <a:r>
               <a:rPr lang="en-US" sz="1500" dirty="0">
                 <a:solidFill>
@@ -5084,14 +5104,14 @@
       </p:sp>
       <p:pic>
         <p:nvPicPr>
-          <p:cNvPr id="26" name="error-query" descr="Foto de consulta de un perro registrado">    </p:cNvPr>
+          <p:cNvPr id="26" name="error-query" descr="Foto de consulta de un perro registrado"/>
           <p:cNvPicPr>
             <a:picLocks noChangeAspect="1"/>
           </p:cNvPicPr>
           <p:nvPr/>
         </p:nvPicPr>
         <p:blipFill>
-          <a:blip r:embed="rId1"/>
+          <a:blip r:embed="rId3"/>
           <a:stretch>
             <a:fillRect/>
           </a:stretch>
@@ -5108,14 +5128,14 @@
       </p:pic>
       <p:pic>
         <p:nvPicPr>
-          <p:cNvPr id="27" name="error-suggested" descr="Perro distinto sugerido por error">    </p:cNvPr>
+          <p:cNvPr id="27" name="error-suggested" descr="Perro distinto sugerido por error"/>
           <p:cNvPicPr>
             <a:picLocks noChangeAspect="1"/>
           </p:cNvPicPr>
           <p:nvPr/>
         </p:nvPicPr>
         <p:blipFill>
-          <a:blip r:embed="rId2"/>
+          <a:blip r:embed="rId4"/>
           <a:stretch>
             <a:fillRect/>
           </a:stretch>
@@ -5151,7 +5171,7 @@
           <a:bodyPr wrap="square" lIns="0" tIns="0" rIns="0" bIns="0" rtlCol="0" anchor="ctr"/>
           <a:lstStyle/>
           <a:p>
-            <a:pPr algn="ctr" indent="0" marL="0">
+            <a:pPr marL="0" indent="0" algn="ctr">
               <a:buNone/>
             </a:pPr>
             <a:r>
@@ -5187,7 +5207,7 @@
           <a:bodyPr wrap="square" lIns="0" tIns="0" rIns="0" bIns="0" rtlCol="0" anchor="ctr"/>
           <a:lstStyle/>
           <a:p>
-            <a:pPr indent="0" marL="0">
+            <a:pPr marL="0" indent="0">
               <a:buNone/>
             </a:pPr>
             <a:r>
@@ -5201,7 +5221,7 @@
             <a:endParaRPr lang="en-US" sz="1200" dirty="0"/>
           </a:p>
           <a:p>
-            <a:pPr indent="0" marL="0">
+            <a:pPr marL="0" indent="0">
               <a:buNone/>
             </a:pPr>
             <a:r>
@@ -5218,7 +5238,7 @@
       </p:sp>
       <p:sp>
         <p:nvSpPr>
-          <p:cNvPr id="25" name="Slide Number Placeholder 0"/>
+          <p:cNvPr id="30" name="Slide Number Placeholder 0"/>
           <p:cNvSpPr>
             <a:spLocks noGrp="1"/>
           </p:cNvSpPr>
@@ -5236,7 +5256,7 @@
           </a:prstGeom>
           <a:extLst>
             <a:ext uri="{C572A759-6A51-4108-AA02-DFA0A04FC94B}">
-              <ma14:wrappingTextBoxFlag xmlns:ma14="http://schemas.microsoft.com/office/mac/drawingml/2011/main" val="0"/>
+              <ma14:wrappingTextBoxFlag xmlns:ma14="http://schemas.microsoft.com/office/mac/drawingml/2011/main" xmlns="" val="0"/>
             </a:ext>
           </a:extLst>
         </p:spPr>
@@ -5254,7 +5274,7 @@
           <a:p>
             <a:pPr algn="r"/>
             <a:fld id="{F7021451-1387-4CA6-816F-3879F97B5CBC}" type="slidenum">
-              <a:rPr b="0" lang="en-US"/>
+              <a:rPr lang="en-US" b="0"/>
               <a:t>4</a:t>
             </a:fld>
             <a:endParaRPr lang="en-US"/>
@@ -5307,7 +5327,7 @@
           <a:bodyPr wrap="square" lIns="0" tIns="0" rIns="0" bIns="0" rtlCol="0" anchor="ctr"/>
           <a:lstStyle/>
           <a:p>
-            <a:pPr indent="0" marL="0">
+            <a:pPr marL="0" indent="0">
               <a:buNone/>
             </a:pPr>
             <a:r>
@@ -5346,7 +5366,7 @@
           <a:bodyPr wrap="square" lIns="0" tIns="0" rIns="0" bIns="0" rtlCol="0" anchor="t"/>
           <a:lstStyle/>
           <a:p>
-            <a:pPr indent="0" marL="0">
+            <a:pPr marL="0" indent="0">
               <a:buNone/>
             </a:pPr>
             <a:r>
@@ -5360,7 +5380,7 @@
             <a:endParaRPr lang="en-US" sz="2400" dirty="0"/>
           </a:p>
           <a:p>
-            <a:pPr indent="0" marL="0">
+            <a:pPr marL="0" indent="0">
               <a:buNone/>
             </a:pPr>
             <a:r>
@@ -5396,6 +5416,13 @@
           </a:solidFill>
           <a:ln/>
         </p:spPr>
+        <p:txBody>
+          <a:bodyPr/>
+          <a:lstStyle/>
+          <a:p>
+            <a:endParaRPr lang="en-US"/>
+          </a:p>
+        </p:txBody>
       </p:sp>
       <p:sp>
         <p:nvSpPr>
@@ -5418,7 +5445,7 @@
           <a:bodyPr wrap="square" lIns="0" tIns="0" rIns="0" bIns="0" rtlCol="0" anchor="ctr"/>
           <a:lstStyle/>
           <a:p>
-            <a:pPr indent="0" marL="0">
+            <a:pPr marL="0" indent="0">
               <a:buNone/>
             </a:pPr>
             <a:r>
@@ -5457,7 +5484,7 @@
           <a:bodyPr wrap="square" lIns="0" tIns="0" rIns="0" bIns="0" rtlCol="0" anchor="ctr"/>
           <a:lstStyle/>
           <a:p>
-            <a:pPr indent="0" marL="0">
+            <a:pPr marL="0" indent="0">
               <a:buNone/>
             </a:pPr>
             <a:r>
@@ -5493,6 +5520,13 @@
           </a:solidFill>
           <a:ln/>
         </p:spPr>
+        <p:txBody>
+          <a:bodyPr/>
+          <a:lstStyle/>
+          <a:p>
+            <a:endParaRPr lang="en-US"/>
+          </a:p>
+        </p:txBody>
       </p:sp>
       <p:sp>
         <p:nvSpPr>
@@ -5515,7 +5549,7 @@
           <a:bodyPr wrap="square" lIns="0" tIns="0" rIns="0" bIns="0" rtlCol="0" anchor="ctr"/>
           <a:lstStyle/>
           <a:p>
-            <a:pPr indent="0" marL="0">
+            <a:pPr marL="0" indent="0">
               <a:buNone/>
             </a:pPr>
             <a:r>
@@ -5554,7 +5588,7 @@
           <a:bodyPr wrap="square" lIns="0" tIns="0" rIns="0" bIns="0" rtlCol="0" anchor="ctr"/>
           <a:lstStyle/>
           <a:p>
-            <a:pPr indent="0" marL="0">
+            <a:pPr marL="0" indent="0">
               <a:buNone/>
             </a:pPr>
             <a:r>
@@ -5590,6 +5624,13 @@
           </a:solidFill>
           <a:ln/>
         </p:spPr>
+        <p:txBody>
+          <a:bodyPr/>
+          <a:lstStyle/>
+          <a:p>
+            <a:endParaRPr lang="en-US"/>
+          </a:p>
+        </p:txBody>
       </p:sp>
       <p:sp>
         <p:nvSpPr>
@@ -5612,7 +5653,7 @@
           <a:bodyPr wrap="square" lIns="0" tIns="0" rIns="0" bIns="0" rtlCol="0" anchor="ctr"/>
           <a:lstStyle/>
           <a:p>
-            <a:pPr indent="0" marL="0">
+            <a:pPr marL="0" indent="0">
               <a:buNone/>
             </a:pPr>
             <a:r>
@@ -5651,7 +5692,7 @@
           <a:bodyPr wrap="square" lIns="0" tIns="0" rIns="0" bIns="0" rtlCol="0" anchor="ctr"/>
           <a:lstStyle/>
           <a:p>
-            <a:pPr indent="0" marL="0">
+            <a:pPr marL="0" indent="0">
               <a:buNone/>
             </a:pPr>
             <a:r>
@@ -5687,7 +5728,7 @@
           <a:bodyPr wrap="square" lIns="0" tIns="0" rIns="0" bIns="0" rtlCol="0" anchor="t"/>
           <a:lstStyle/>
           <a:p>
-            <a:pPr indent="0" marL="0">
+            <a:pPr marL="0" indent="0">
               <a:buNone/>
             </a:pPr>
             <a:r>
@@ -5704,7 +5745,7 @@
             <a:endParaRPr lang="en-US" sz="2200" dirty="0"/>
           </a:p>
           <a:p>
-            <a:pPr indent="0" marL="0">
+            <a:pPr marL="0" indent="0">
               <a:buNone/>
             </a:pPr>
             <a:r>
@@ -5722,9 +5763,11 @@
       <p:sp>
         <p:nvSpPr>
           <p:cNvPr id="15" name="Text 0"/>
-          <p:cNvSpPr/>
+          <p:cNvSpPr>
+            <a:spLocks noGrp="1"/>
+          </p:cNvSpPr>
           <p:nvPr>
-            <p:ph idx="100" type="title" hasCustomPrompt="1"/>
+            <p:ph type="title" idx="100" hasCustomPrompt="1"/>
           </p:nvPr>
         </p:nvSpPr>
         <p:spPr>
@@ -5742,7 +5785,7 @@
           <a:bodyPr wrap="square" lIns="0" tIns="0" rIns="0" bIns="0" rtlCol="0" anchor="b"/>
           <a:lstStyle/>
           <a:p>
-            <a:pPr algn="l" indent="0" marL="0">
+            <a:pPr marL="0" indent="0" algn="l">
               <a:buNone/>
             </a:pPr>
             <a:endParaRPr lang="en-US" sz="4400" dirty="0"/>
@@ -5752,9 +5795,11 @@
       <p:sp>
         <p:nvSpPr>
           <p:cNvPr id="16" name="Text 0"/>
-          <p:cNvSpPr/>
+          <p:cNvSpPr>
+            <a:spLocks noGrp="1"/>
+          </p:cNvSpPr>
           <p:nvPr>
-            <p:ph idx="101" type="body" hasCustomPrompt="1"/>
+            <p:ph type="body" idx="101" hasCustomPrompt="1"/>
           </p:nvPr>
         </p:nvSpPr>
         <p:spPr>
@@ -5772,7 +5817,7 @@
           <a:bodyPr wrap="square" lIns="0" tIns="0" rIns="0" bIns="0" rtlCol="0" anchor="t"/>
           <a:lstStyle/>
           <a:p>
-            <a:pPr algn="l" indent="0" marL="0">
+            <a:pPr marL="0" indent="0" algn="l">
               <a:buNone/>
             </a:pPr>
             <a:endParaRPr lang="en-US" sz="2000" dirty="0"/>
@@ -5782,9 +5827,11 @@
       <p:sp>
         <p:nvSpPr>
           <p:cNvPr id="17" name="Text 0"/>
-          <p:cNvSpPr/>
+          <p:cNvSpPr>
+            <a:spLocks noGrp="1"/>
+          </p:cNvSpPr>
           <p:nvPr>
-            <p:ph idx="102" type="body" hasCustomPrompt="1"/>
+            <p:ph type="body" idx="102" hasCustomPrompt="1"/>
           </p:nvPr>
         </p:nvSpPr>
         <p:spPr>
@@ -5802,7 +5849,7 @@
           <a:bodyPr wrap="square" lIns="0" tIns="0" rIns="0" bIns="0" rtlCol="0" anchor="t"/>
           <a:lstStyle/>
           <a:p>
-            <a:pPr algn="l" indent="0" marL="0">
+            <a:pPr marL="0" indent="0" algn="l">
               <a:buNone/>
             </a:pPr>
             <a:endParaRPr lang="en-US" sz="1400" dirty="0"/>
@@ -5837,9 +5884,11 @@
       <p:sp>
         <p:nvSpPr>
           <p:cNvPr id="2" name="Text 0"/>
-          <p:cNvSpPr/>
+          <p:cNvSpPr>
+            <a:spLocks noGrp="1"/>
+          </p:cNvSpPr>
           <p:nvPr>
-            <p:ph idx="100" type="title" hasCustomPrompt="1"/>
+            <p:ph type="title" idx="100" hasCustomPrompt="1"/>
           </p:nvPr>
         </p:nvSpPr>
         <p:spPr>
@@ -5857,7 +5906,7 @@
           <a:bodyPr wrap="square" lIns="0" tIns="0" rIns="0" bIns="0" rtlCol="0" anchor="ctr"/>
           <a:lstStyle/>
           <a:p>
-            <a:pPr indent="0" marL="0">
+            <a:pPr marL="0" indent="0">
               <a:buNone/>
             </a:pPr>
             <a:r>
@@ -5895,8 +5944,20 @@
             <a:tbl>
               <a:tblPr/>
               <a:tblGrid>
-                <a:gridCol w="1417320"/>
-                <a:gridCol w="4023360"/>
+                <a:gridCol w="1417320">
+                  <a:extLst>
+                    <a:ext uri="{9D8B030D-6E8A-4147-A177-3AD203B41FA5}">
+                      <a16:colId xmlns:a16="http://schemas.microsoft.com/office/drawing/2014/main" val="20000"/>
+                    </a:ext>
+                  </a:extLst>
+                </a:gridCol>
+                <a:gridCol w="4023360">
+                  <a:extLst>
+                    <a:ext uri="{9D8B030D-6E8A-4147-A177-3AD203B41FA5}">
+                      <a16:colId xmlns:a16="http://schemas.microsoft.com/office/drawing/2014/main" val="20001"/>
+                    </a:ext>
+                  </a:extLst>
+                </a:gridCol>
               </a:tblGrid>
               <a:tr h="0">
                 <a:tc>
@@ -5904,7 +5965,7 @@
                     <a:bodyPr/>
                     <a:lstStyle/>
                     <a:p>
-                      <a:pPr indent="0" marL="0">
+                      <a:pPr marL="0" indent="0">
                         <a:buNone/>
                       </a:pPr>
                       <a:r>
@@ -5965,7 +6026,7 @@
                     <a:bodyPr/>
                     <a:lstStyle/>
                     <a:p>
-                      <a:pPr indent="0" marL="0">
+                      <a:pPr marL="0" indent="0">
                         <a:buNone/>
                       </a:pPr>
                       <a:r>
@@ -6021,6 +6082,11 @@
                     </a:solidFill>
                   </a:tcPr>
                 </a:tc>
+                <a:extLst>
+                  <a:ext uri="{0D108BD9-81ED-4DB2-BD59-A6C34878D82A}">
+                    <a16:rowId xmlns:a16="http://schemas.microsoft.com/office/drawing/2014/main" val="10000"/>
+                  </a:ext>
+                </a:extLst>
               </a:tr>
               <a:tr h="0">
                 <a:tc>
@@ -6028,7 +6094,7 @@
                     <a:bodyPr/>
                     <a:lstStyle/>
                     <a:p>
-                      <a:pPr indent="0" marL="0">
+                      <a:pPr marL="0" indent="0">
                         <a:buNone/>
                       </a:pPr>
                       <a:r>
@@ -6089,7 +6155,7 @@
                     <a:bodyPr/>
                     <a:lstStyle/>
                     <a:p>
-                      <a:pPr indent="0" marL="0">
+                      <a:pPr marL="0" indent="0">
                         <a:buNone/>
                       </a:pPr>
                       <a:r>
@@ -6145,6 +6211,11 @@
                     </a:solidFill>
                   </a:tcPr>
                 </a:tc>
+                <a:extLst>
+                  <a:ext uri="{0D108BD9-81ED-4DB2-BD59-A6C34878D82A}">
+                    <a16:rowId xmlns:a16="http://schemas.microsoft.com/office/drawing/2014/main" val="10001"/>
+                  </a:ext>
+                </a:extLst>
               </a:tr>
               <a:tr h="0">
                 <a:tc>
@@ -6152,7 +6223,7 @@
                     <a:bodyPr/>
                     <a:lstStyle/>
                     <a:p>
-                      <a:pPr indent="0" marL="0">
+                      <a:pPr marL="0" indent="0">
                         <a:buNone/>
                       </a:pPr>
                       <a:r>
@@ -6213,7 +6284,7 @@
                     <a:bodyPr/>
                     <a:lstStyle/>
                     <a:p>
-                      <a:pPr indent="0" marL="0">
+                      <a:pPr marL="0" indent="0">
                         <a:buNone/>
                       </a:pPr>
                       <a:r>
@@ -6269,6 +6340,11 @@
                     </a:solidFill>
                   </a:tcPr>
                 </a:tc>
+                <a:extLst>
+                  <a:ext uri="{0D108BD9-81ED-4DB2-BD59-A6C34878D82A}">
+                    <a16:rowId xmlns:a16="http://schemas.microsoft.com/office/drawing/2014/main" val="10002"/>
+                  </a:ext>
+                </a:extLst>
               </a:tr>
               <a:tr h="0">
                 <a:tc>
@@ -6276,7 +6352,7 @@
                     <a:bodyPr/>
                     <a:lstStyle/>
                     <a:p>
-                      <a:pPr indent="0" marL="0">
+                      <a:pPr marL="0" indent="0">
                         <a:buNone/>
                       </a:pPr>
                       <a:r>
@@ -6337,7 +6413,7 @@
                     <a:bodyPr/>
                     <a:lstStyle/>
                     <a:p>
-                      <a:pPr indent="0" marL="0">
+                      <a:pPr marL="0" indent="0">
                         <a:buNone/>
                       </a:pPr>
                       <a:r>
@@ -6393,6 +6469,11 @@
                     </a:solidFill>
                   </a:tcPr>
                 </a:tc>
+                <a:extLst>
+                  <a:ext uri="{0D108BD9-81ED-4DB2-BD59-A6C34878D82A}">
+                    <a16:rowId xmlns:a16="http://schemas.microsoft.com/office/drawing/2014/main" val="10003"/>
+                  </a:ext>
+                </a:extLst>
               </a:tr>
               <a:tr h="0">
                 <a:tc>
@@ -6400,7 +6481,7 @@
                     <a:bodyPr/>
                     <a:lstStyle/>
                     <a:p>
-                      <a:pPr indent="0" marL="0">
+                      <a:pPr marL="0" indent="0">
                         <a:buNone/>
                       </a:pPr>
                       <a:r>
@@ -6461,7 +6542,7 @@
                     <a:bodyPr/>
                     <a:lstStyle/>
                     <a:p>
-                      <a:pPr indent="0" marL="0">
+                      <a:pPr marL="0" indent="0">
                         <a:buNone/>
                       </a:pPr>
                       <a:r>
@@ -6517,6 +6598,11 @@
                     </a:solidFill>
                   </a:tcPr>
                 </a:tc>
+                <a:extLst>
+                  <a:ext uri="{0D108BD9-81ED-4DB2-BD59-A6C34878D82A}">
+                    <a16:rowId xmlns:a16="http://schemas.microsoft.com/office/drawing/2014/main" val="10004"/>
+                  </a:ext>
+                </a:extLst>
               </a:tr>
               <a:tr h="0">
                 <a:tc>
@@ -6524,7 +6610,7 @@
                     <a:bodyPr/>
                     <a:lstStyle/>
                     <a:p>
-                      <a:pPr indent="0" marL="0">
+                      <a:pPr marL="0" indent="0">
                         <a:buNone/>
                       </a:pPr>
                       <a:r>
@@ -6585,7 +6671,7 @@
                     <a:bodyPr/>
                     <a:lstStyle/>
                     <a:p>
-                      <a:pPr indent="0" marL="0">
+                      <a:pPr marL="0" indent="0">
                         <a:buNone/>
                       </a:pPr>
                       <a:r>
@@ -6641,6 +6727,11 @@
                     </a:solidFill>
                   </a:tcPr>
                 </a:tc>
+                <a:extLst>
+                  <a:ext uri="{0D108BD9-81ED-4DB2-BD59-A6C34878D82A}">
+                    <a16:rowId xmlns:a16="http://schemas.microsoft.com/office/drawing/2014/main" val="10005"/>
+                  </a:ext>
+                </a:extLst>
               </a:tr>
             </a:tbl>
           </a:graphicData>
@@ -6669,8 +6760,20 @@
             <a:tbl>
               <a:tblPr/>
               <a:tblGrid>
-                <a:gridCol w="1417320"/>
-                <a:gridCol w="4023360"/>
+                <a:gridCol w="1417320">
+                  <a:extLst>
+                    <a:ext uri="{9D8B030D-6E8A-4147-A177-3AD203B41FA5}">
+                      <a16:colId xmlns:a16="http://schemas.microsoft.com/office/drawing/2014/main" val="20000"/>
+                    </a:ext>
+                  </a:extLst>
+                </a:gridCol>
+                <a:gridCol w="4023360">
+                  <a:extLst>
+                    <a:ext uri="{9D8B030D-6E8A-4147-A177-3AD203B41FA5}">
+                      <a16:colId xmlns:a16="http://schemas.microsoft.com/office/drawing/2014/main" val="20001"/>
+                    </a:ext>
+                  </a:extLst>
+                </a:gridCol>
               </a:tblGrid>
               <a:tr h="0">
                 <a:tc>
@@ -6678,7 +6781,7 @@
                     <a:bodyPr/>
                     <a:lstStyle/>
                     <a:p>
-                      <a:pPr indent="0" marL="0">
+                      <a:pPr marL="0" indent="0">
                         <a:buNone/>
                       </a:pPr>
                       <a:r>
@@ -6739,7 +6842,7 @@
                     <a:bodyPr/>
                     <a:lstStyle/>
                     <a:p>
-                      <a:pPr indent="0" marL="0">
+                      <a:pPr marL="0" indent="0">
                         <a:buNone/>
                       </a:pPr>
                       <a:r>
@@ -6795,6 +6898,11 @@
                     </a:solidFill>
                   </a:tcPr>
                 </a:tc>
+                <a:extLst>
+                  <a:ext uri="{0D108BD9-81ED-4DB2-BD59-A6C34878D82A}">
+                    <a16:rowId xmlns:a16="http://schemas.microsoft.com/office/drawing/2014/main" val="10000"/>
+                  </a:ext>
+                </a:extLst>
               </a:tr>
               <a:tr h="0">
                 <a:tc>
@@ -6802,7 +6910,7 @@
                     <a:bodyPr/>
                     <a:lstStyle/>
                     <a:p>
-                      <a:pPr indent="0" marL="0">
+                      <a:pPr marL="0" indent="0">
                         <a:buNone/>
                       </a:pPr>
                       <a:r>
@@ -6863,7 +6971,7 @@
                     <a:bodyPr/>
                     <a:lstStyle/>
                     <a:p>
-                      <a:pPr indent="0" marL="0">
+                      <a:pPr marL="0" indent="0">
                         <a:buNone/>
                       </a:pPr>
                       <a:r>
@@ -6919,6 +7027,11 @@
                     </a:solidFill>
                   </a:tcPr>
                 </a:tc>
+                <a:extLst>
+                  <a:ext uri="{0D108BD9-81ED-4DB2-BD59-A6C34878D82A}">
+                    <a16:rowId xmlns:a16="http://schemas.microsoft.com/office/drawing/2014/main" val="10001"/>
+                  </a:ext>
+                </a:extLst>
               </a:tr>
               <a:tr h="0">
                 <a:tc>
@@ -6926,7 +7039,7 @@
                     <a:bodyPr/>
                     <a:lstStyle/>
                     <a:p>
-                      <a:pPr indent="0" marL="0">
+                      <a:pPr marL="0" indent="0">
                         <a:buNone/>
                       </a:pPr>
                       <a:r>
@@ -6987,7 +7100,7 @@
                     <a:bodyPr/>
                     <a:lstStyle/>
                     <a:p>
-                      <a:pPr indent="0" marL="0">
+                      <a:pPr marL="0" indent="0">
                         <a:buNone/>
                       </a:pPr>
                       <a:r>
@@ -7043,6 +7156,11 @@
                     </a:solidFill>
                   </a:tcPr>
                 </a:tc>
+                <a:extLst>
+                  <a:ext uri="{0D108BD9-81ED-4DB2-BD59-A6C34878D82A}">
+                    <a16:rowId xmlns:a16="http://schemas.microsoft.com/office/drawing/2014/main" val="10002"/>
+                  </a:ext>
+                </a:extLst>
               </a:tr>
               <a:tr h="0">
                 <a:tc>
@@ -7050,7 +7168,7 @@
                     <a:bodyPr/>
                     <a:lstStyle/>
                     <a:p>
-                      <a:pPr indent="0" marL="0">
+                      <a:pPr marL="0" indent="0">
                         <a:buNone/>
                       </a:pPr>
                       <a:r>
@@ -7111,7 +7229,7 @@
                     <a:bodyPr/>
                     <a:lstStyle/>
                     <a:p>
-                      <a:pPr indent="0" marL="0">
+                      <a:pPr marL="0" indent="0">
                         <a:buNone/>
                       </a:pPr>
                       <a:r>
@@ -7167,6 +7285,11 @@
                     </a:solidFill>
                   </a:tcPr>
                 </a:tc>
+                <a:extLst>
+                  <a:ext uri="{0D108BD9-81ED-4DB2-BD59-A6C34878D82A}">
+                    <a16:rowId xmlns:a16="http://schemas.microsoft.com/office/drawing/2014/main" val="10003"/>
+                  </a:ext>
+                </a:extLst>
               </a:tr>
               <a:tr h="0">
                 <a:tc>
@@ -7174,7 +7297,7 @@
                     <a:bodyPr/>
                     <a:lstStyle/>
                     <a:p>
-                      <a:pPr indent="0" marL="0">
+                      <a:pPr marL="0" indent="0">
                         <a:buNone/>
                       </a:pPr>
                       <a:r>
@@ -7235,7 +7358,7 @@
                     <a:bodyPr/>
                     <a:lstStyle/>
                     <a:p>
-                      <a:pPr indent="0" marL="0">
+                      <a:pPr marL="0" indent="0">
                         <a:buNone/>
                       </a:pPr>
                       <a:r>
@@ -7291,6 +7414,11 @@
                     </a:solidFill>
                   </a:tcPr>
                 </a:tc>
+                <a:extLst>
+                  <a:ext uri="{0D108BD9-81ED-4DB2-BD59-A6C34878D82A}">
+                    <a16:rowId xmlns:a16="http://schemas.microsoft.com/office/drawing/2014/main" val="10004"/>
+                  </a:ext>
+                </a:extLst>
               </a:tr>
               <a:tr h="0">
                 <a:tc>
@@ -7298,7 +7426,7 @@
                     <a:bodyPr/>
                     <a:lstStyle/>
                     <a:p>
-                      <a:pPr indent="0" marL="0">
+                      <a:pPr marL="0" indent="0">
                         <a:buNone/>
                       </a:pPr>
                       <a:r>
@@ -7359,7 +7487,7 @@
                     <a:bodyPr/>
                     <a:lstStyle/>
                     <a:p>
-                      <a:pPr indent="0" marL="0">
+                      <a:pPr marL="0" indent="0">
                         <a:buNone/>
                       </a:pPr>
                       <a:r>
@@ -7415,6 +7543,11 @@
                     </a:solidFill>
                   </a:tcPr>
                 </a:tc>
+                <a:extLst>
+                  <a:ext uri="{0D108BD9-81ED-4DB2-BD59-A6C34878D82A}">
+                    <a16:rowId xmlns:a16="http://schemas.microsoft.com/office/drawing/2014/main" val="10005"/>
+                  </a:ext>
+                </a:extLst>
               </a:tr>
             </a:tbl>
           </a:graphicData>
@@ -7440,7 +7573,7 @@
           </a:prstGeom>
           <a:extLst>
             <a:ext uri="{C572A759-6A51-4108-AA02-DFA0A04FC94B}">
-              <ma14:wrappingTextBoxFlag xmlns:ma14="http://schemas.microsoft.com/office/mac/drawingml/2011/main" val="0"/>
+              <ma14:wrappingTextBoxFlag xmlns:ma14="http://schemas.microsoft.com/office/mac/drawingml/2011/main" xmlns="" val="0"/>
             </a:ext>
           </a:extLst>
         </p:spPr>
@@ -7458,7 +7591,7 @@
           <a:p>
             <a:pPr algn="r"/>
             <a:fld id="{F7021451-1387-4CA6-816F-3879F97B5CBC}" type="slidenum">
-              <a:rPr b="0" lang="en-US"/>
+              <a:rPr lang="en-US" b="0"/>
               <a:t>6</a:t>
             </a:fld>
             <a:endParaRPr lang="en-US"/>
@@ -7493,9 +7626,11 @@
       <p:sp>
         <p:nvSpPr>
           <p:cNvPr id="2" name="Text 0"/>
-          <p:cNvSpPr/>
+          <p:cNvSpPr>
+            <a:spLocks noGrp="1"/>
+          </p:cNvSpPr>
           <p:nvPr>
-            <p:ph idx="100" type="title" hasCustomPrompt="1"/>
+            <p:ph type="title" idx="100" hasCustomPrompt="1"/>
           </p:nvPr>
         </p:nvSpPr>
         <p:spPr>
@@ -7513,7 +7648,7 @@
           <a:bodyPr wrap="square" lIns="0" tIns="0" rIns="0" bIns="0" rtlCol="0" anchor="ctr"/>
           <a:lstStyle/>
           <a:p>
-            <a:pPr indent="0" marL="0">
+            <a:pPr marL="0" indent="0">
               <a:buNone/>
             </a:pPr>
             <a:r>
@@ -7549,6 +7684,13 @@
           </a:solidFill>
           <a:ln/>
         </p:spPr>
+        <p:txBody>
+          <a:bodyPr/>
+          <a:lstStyle/>
+          <a:p>
+            <a:endParaRPr lang="en-US"/>
+          </a:p>
+        </p:txBody>
       </p:sp>
       <p:sp>
         <p:nvSpPr>
@@ -7571,7 +7713,7 @@
           <a:bodyPr wrap="square" lIns="0" tIns="0" rIns="0" bIns="0" rtlCol="0" anchor="t"/>
           <a:lstStyle/>
           <a:p>
-            <a:pPr indent="0" marL="0">
+            <a:pPr marL="0" indent="0">
               <a:spcAft>
                 <a:spcPts val="400"/>
               </a:spcAft>
@@ -7588,7 +7730,7 @@
             <a:endParaRPr lang="en-US" sz="1500" dirty="0"/>
           </a:p>
           <a:p>
-            <a:pPr indent="0" marL="0">
+            <a:pPr marL="0" indent="0">
               <a:spcAft>
                 <a:spcPts val="400"/>
               </a:spcAft>
@@ -7627,6 +7769,13 @@
           </a:solidFill>
           <a:ln/>
         </p:spPr>
+        <p:txBody>
+          <a:bodyPr/>
+          <a:lstStyle/>
+          <a:p>
+            <a:endParaRPr lang="en-US"/>
+          </a:p>
+        </p:txBody>
       </p:sp>
       <p:sp>
         <p:nvSpPr>
@@ -7649,7 +7798,7 @@
           <a:bodyPr wrap="square" lIns="0" tIns="0" rIns="0" bIns="0" rtlCol="0" anchor="t"/>
           <a:lstStyle/>
           <a:p>
-            <a:pPr indent="0" marL="0">
+            <a:pPr marL="0" indent="0">
               <a:spcAft>
                 <a:spcPts val="400"/>
               </a:spcAft>
@@ -7666,7 +7815,7 @@
             <a:endParaRPr lang="en-US" sz="1500" dirty="0"/>
           </a:p>
           <a:p>
-            <a:pPr indent="0" marL="0">
+            <a:pPr marL="0" indent="0">
               <a:spcAft>
                 <a:spcPts val="400"/>
               </a:spcAft>
@@ -7705,6 +7854,13 @@
           </a:solidFill>
           <a:ln/>
         </p:spPr>
+        <p:txBody>
+          <a:bodyPr/>
+          <a:lstStyle/>
+          <a:p>
+            <a:endParaRPr lang="en-US"/>
+          </a:p>
+        </p:txBody>
       </p:sp>
       <p:sp>
         <p:nvSpPr>
@@ -7727,7 +7883,7 @@
           <a:bodyPr wrap="square" lIns="0" tIns="0" rIns="0" bIns="0" rtlCol="0" anchor="t"/>
           <a:lstStyle/>
           <a:p>
-            <a:pPr indent="0" marL="0">
+            <a:pPr marL="0" indent="0">
               <a:spcAft>
                 <a:spcPts val="400"/>
               </a:spcAft>
@@ -7744,7 +7900,7 @@
             <a:endParaRPr lang="en-US" sz="1500" dirty="0"/>
           </a:p>
           <a:p>
-            <a:pPr indent="0" marL="0">
+            <a:pPr marL="0" indent="0">
               <a:spcAft>
                 <a:spcPts val="400"/>
               </a:spcAft>
@@ -7783,6 +7939,13 @@
           </a:solidFill>
           <a:ln/>
         </p:spPr>
+        <p:txBody>
+          <a:bodyPr/>
+          <a:lstStyle/>
+          <a:p>
+            <a:endParaRPr lang="en-US"/>
+          </a:p>
+        </p:txBody>
       </p:sp>
       <p:sp>
         <p:nvSpPr>
@@ -7805,7 +7968,7 @@
           <a:bodyPr wrap="square" lIns="0" tIns="0" rIns="0" bIns="0" rtlCol="0" anchor="t"/>
           <a:lstStyle/>
           <a:p>
-            <a:pPr indent="0" marL="0">
+            <a:pPr marL="0" indent="0">
               <a:spcAft>
                 <a:spcPts val="400"/>
               </a:spcAft>
@@ -7822,7 +7985,7 @@
             <a:endParaRPr lang="en-US" sz="1500" dirty="0"/>
           </a:p>
           <a:p>
-            <a:pPr indent="0" marL="0">
+            <a:pPr marL="0" indent="0">
               <a:spcAft>
                 <a:spcPts val="400"/>
               </a:spcAft>
@@ -7861,6 +8024,13 @@
           </a:solidFill>
           <a:ln/>
         </p:spPr>
+        <p:txBody>
+          <a:bodyPr/>
+          <a:lstStyle/>
+          <a:p>
+            <a:endParaRPr lang="en-US"/>
+          </a:p>
+        </p:txBody>
       </p:sp>
       <p:sp>
         <p:nvSpPr>
@@ -7883,7 +8053,7 @@
           <a:bodyPr wrap="square" lIns="0" tIns="0" rIns="0" bIns="0" rtlCol="0" anchor="t"/>
           <a:lstStyle/>
           <a:p>
-            <a:pPr indent="0" marL="0">
+            <a:pPr marL="0" indent="0">
               <a:spcAft>
                 <a:spcPts val="400"/>
               </a:spcAft>
@@ -7900,7 +8070,7 @@
             <a:endParaRPr lang="en-US" sz="1500" dirty="0"/>
           </a:p>
           <a:p>
-            <a:pPr indent="0" marL="0">
+            <a:pPr marL="0" indent="0">
               <a:spcAft>
                 <a:spcPts val="400"/>
               </a:spcAft>
@@ -7939,6 +8109,13 @@
           </a:solidFill>
           <a:ln/>
         </p:spPr>
+        <p:txBody>
+          <a:bodyPr/>
+          <a:lstStyle/>
+          <a:p>
+            <a:endParaRPr lang="en-US"/>
+          </a:p>
+        </p:txBody>
       </p:sp>
       <p:sp>
         <p:nvSpPr>
@@ -7961,7 +8138,7 @@
           <a:bodyPr wrap="square" lIns="0" tIns="0" rIns="0" bIns="0" rtlCol="0" anchor="t"/>
           <a:lstStyle/>
           <a:p>
-            <a:pPr indent="0" marL="0">
+            <a:pPr marL="0" indent="0">
               <a:spcAft>
                 <a:spcPts val="400"/>
               </a:spcAft>
@@ -7978,7 +8155,7 @@
             <a:endParaRPr lang="en-US" sz="1500" dirty="0"/>
           </a:p>
           <a:p>
-            <a:pPr indent="0" marL="0">
+            <a:pPr marL="0" indent="0">
               <a:spcAft>
                 <a:spcPts val="400"/>
               </a:spcAft>
@@ -8016,7 +8193,7 @@
           </a:prstGeom>
           <a:extLst>
             <a:ext uri="{C572A759-6A51-4108-AA02-DFA0A04FC94B}">
-              <ma14:wrappingTextBoxFlag xmlns:ma14="http://schemas.microsoft.com/office/mac/drawingml/2011/main" val="0"/>
+              <ma14:wrappingTextBoxFlag xmlns:ma14="http://schemas.microsoft.com/office/mac/drawingml/2011/main" xmlns="" val="0"/>
             </a:ext>
           </a:extLst>
         </p:spPr>
@@ -8034,7 +8211,7 @@
           <a:p>
             <a:pPr algn="r"/>
             <a:fld id="{F7021451-1387-4CA6-816F-3879F97B5CBC}" type="slidenum">
-              <a:rPr b="0" lang="en-US"/>
+              <a:rPr lang="en-US" b="0"/>
               <a:t>7</a:t>
             </a:fld>
             <a:endParaRPr lang="en-US"/>
@@ -8342,4 +8519,319 @@
     </a:ext>
   </a:extLst>
 </a:theme>
+</file>
+
+<file path=ppt/theme/theme2.xml><?xml version="1.0" encoding="utf-8"?>
+<a:theme xmlns:a="http://schemas.openxmlformats.org/drawingml/2006/main" name="Office Theme">
+  <a:themeElements>
+    <a:clrScheme name="Office">
+      <a:dk1>
+        <a:sysClr val="windowText" lastClr="000000"/>
+      </a:dk1>
+      <a:lt1>
+        <a:sysClr val="window" lastClr="FFFFFF"/>
+      </a:lt1>
+      <a:dk2>
+        <a:srgbClr val="0E2841"/>
+      </a:dk2>
+      <a:lt2>
+        <a:srgbClr val="E8E8E8"/>
+      </a:lt2>
+      <a:accent1>
+        <a:srgbClr val="156082"/>
+      </a:accent1>
+      <a:accent2>
+        <a:srgbClr val="E97132"/>
+      </a:accent2>
+      <a:accent3>
+        <a:srgbClr val="196B24"/>
+      </a:accent3>
+      <a:accent4>
+        <a:srgbClr val="0F9ED5"/>
+      </a:accent4>
+      <a:accent5>
+        <a:srgbClr val="A02B93"/>
+      </a:accent5>
+      <a:accent6>
+        <a:srgbClr val="4EA72E"/>
+      </a:accent6>
+      <a:hlink>
+        <a:srgbClr val="467886"/>
+      </a:hlink>
+      <a:folHlink>
+        <a:srgbClr val="96607D"/>
+      </a:folHlink>
+    </a:clrScheme>
+    <a:fontScheme name="Office">
+      <a:majorFont>
+        <a:latin typeface="Aptos Display" panose="02110004020202020204"/>
+        <a:ea typeface=""/>
+        <a:cs typeface=""/>
+        <a:font script="Jpan" typeface="游ゴシック Light"/>
+        <a:font script="Hang" typeface="맑은 고딕"/>
+        <a:font script="Hans" typeface="等线 Light"/>
+        <a:font script="Hant" typeface="新細明體"/>
+        <a:font script="Arab" typeface="Times New Roman"/>
+        <a:font script="Hebr" typeface="Times New Roman"/>
+        <a:font script="Thai" typeface="Angsana New"/>
+        <a:font script="Ethi" typeface="Nyala"/>
+        <a:font script="Beng" typeface="Vrinda"/>
+        <a:font script="Gujr" typeface="Shruti"/>
+        <a:font script="Khmr" typeface="MoolBoran"/>
+        <a:font script="Knda" typeface="Tunga"/>
+        <a:font script="Guru" typeface="Raavi"/>
+        <a:font script="Cans" typeface="Euphemia"/>
+        <a:font script="Cher" typeface="Plantagenet Cherokee"/>
+        <a:font script="Yiii" typeface="Microsoft Yi Baiti"/>
+        <a:font script="Tibt" typeface="Microsoft Himalaya"/>
+        <a:font script="Thaa" typeface="MV Boli"/>
+        <a:font script="Deva" typeface="Mangal"/>
+        <a:font script="Telu" typeface="Gautami"/>
+        <a:font script="Taml" typeface="Latha"/>
+        <a:font script="Syrc" typeface="Estrangelo Edessa"/>
+        <a:font script="Orya" typeface="Kalinga"/>
+        <a:font script="Mlym" typeface="Kartika"/>
+        <a:font script="Laoo" typeface="DokChampa"/>
+        <a:font script="Sinh" typeface="Iskoola Pota"/>
+        <a:font script="Mong" typeface="Mongolian Baiti"/>
+        <a:font script="Viet" typeface="Times New Roman"/>
+        <a:font script="Uigh" typeface="Microsoft Uighur"/>
+        <a:font script="Geor" typeface="Sylfaen"/>
+        <a:font script="Armn" typeface="Arial"/>
+        <a:font script="Bugi" typeface="Leelawadee UI"/>
+        <a:font script="Bopo" typeface="Microsoft JhengHei"/>
+        <a:font script="Java" typeface="Javanese Text"/>
+        <a:font script="Lisu" typeface="Segoe UI"/>
+        <a:font script="Mymr" typeface="Myanmar Text"/>
+        <a:font script="Nkoo" typeface="Ebrima"/>
+        <a:font script="Olck" typeface="Nirmala UI"/>
+        <a:font script="Osma" typeface="Ebrima"/>
+        <a:font script="Phag" typeface="Phagspa"/>
+        <a:font script="Syrn" typeface="Estrangelo Edessa"/>
+        <a:font script="Syrj" typeface="Estrangelo Edessa"/>
+        <a:font script="Syre" typeface="Estrangelo Edessa"/>
+        <a:font script="Sora" typeface="Nirmala UI"/>
+        <a:font script="Tale" typeface="Microsoft Tai Le"/>
+        <a:font script="Talu" typeface="Microsoft New Tai Lue"/>
+        <a:font script="Tfng" typeface="Ebrima"/>
+      </a:majorFont>
+      <a:minorFont>
+        <a:latin typeface="Aptos" panose="02110004020202020204"/>
+        <a:ea typeface=""/>
+        <a:cs typeface=""/>
+        <a:font script="Jpan" typeface="游ゴシック"/>
+        <a:font script="Hang" typeface="맑은 고딕"/>
+        <a:font script="Hans" typeface="等线"/>
+        <a:font script="Hant" typeface="新細明體"/>
+        <a:font script="Arab" typeface="Arial"/>
+        <a:font script="Hebr" typeface="Arial"/>
+        <a:font script="Thai" typeface="Cordia New"/>
+        <a:font script="Ethi" typeface="Nyala"/>
+        <a:font script="Beng" typeface="Vrinda"/>
+        <a:font script="Gujr" typeface="Shruti"/>
+        <a:font script="Khmr" typeface="DaunPenh"/>
+        <a:font script="Knda" typeface="Tunga"/>
+        <a:font script="Guru" typeface="Raavi"/>
+        <a:font script="Cans" typeface="Euphemia"/>
+        <a:font script="Cher" typeface="Plantagenet Cherokee"/>
+        <a:font script="Yiii" typeface="Microsoft Yi Baiti"/>
+        <a:font script="Tibt" typeface="Microsoft Himalaya"/>
+        <a:font script="Thaa" typeface="MV Boli"/>
+        <a:font script="Deva" typeface="Mangal"/>
+        <a:font script="Telu" typeface="Gautami"/>
+        <a:font script="Taml" typeface="Latha"/>
+        <a:font script="Syrc" typeface="Estrangelo Edessa"/>
+        <a:font script="Orya" typeface="Kalinga"/>
+        <a:font script="Mlym" typeface="Kartika"/>
+        <a:font script="Laoo" typeface="DokChampa"/>
+        <a:font script="Sinh" typeface="Iskoola Pota"/>
+        <a:font script="Mong" typeface="Mongolian Baiti"/>
+        <a:font script="Viet" typeface="Arial"/>
+        <a:font script="Uigh" typeface="Microsoft Uighur"/>
+        <a:font script="Geor" typeface="Sylfaen"/>
+        <a:font script="Armn" typeface="Arial"/>
+        <a:font script="Bugi" typeface="Leelawadee UI"/>
+        <a:font script="Bopo" typeface="Microsoft JhengHei"/>
+        <a:font script="Java" typeface="Javanese Text"/>
+        <a:font script="Lisu" typeface="Segoe UI"/>
+        <a:font script="Mymr" typeface="Myanmar Text"/>
+        <a:font script="Nkoo" typeface="Ebrima"/>
+        <a:font script="Olck" typeface="Nirmala UI"/>
+        <a:font script="Osma" typeface="Ebrima"/>
+        <a:font script="Phag" typeface="Phagspa"/>
+        <a:font script="Syrn" typeface="Estrangelo Edessa"/>
+        <a:font script="Syrj" typeface="Estrangelo Edessa"/>
+        <a:font script="Syre" typeface="Estrangelo Edessa"/>
+        <a:font script="Sora" typeface="Nirmala UI"/>
+        <a:font script="Tale" typeface="Microsoft Tai Le"/>
+        <a:font script="Talu" typeface="Microsoft New Tai Lue"/>
+        <a:font script="Tfng" typeface="Ebrima"/>
+      </a:minorFont>
+    </a:fontScheme>
+    <a:fmtScheme name="Office">
+      <a:fillStyleLst>
+        <a:solidFill>
+          <a:schemeClr val="phClr"/>
+        </a:solidFill>
+        <a:gradFill rotWithShape="1">
+          <a:gsLst>
+            <a:gs pos="0">
+              <a:schemeClr val="phClr">
+                <a:lumMod val="110000"/>
+                <a:satMod val="105000"/>
+                <a:tint val="67000"/>
+              </a:schemeClr>
+            </a:gs>
+            <a:gs pos="50000">
+              <a:schemeClr val="phClr">
+                <a:lumMod val="105000"/>
+                <a:satMod val="103000"/>
+                <a:tint val="73000"/>
+              </a:schemeClr>
+            </a:gs>
+            <a:gs pos="100000">
+              <a:schemeClr val="phClr">
+                <a:lumMod val="105000"/>
+                <a:satMod val="109000"/>
+                <a:tint val="81000"/>
+              </a:schemeClr>
+            </a:gs>
+          </a:gsLst>
+          <a:lin ang="5400000" scaled="0"/>
+        </a:gradFill>
+        <a:gradFill rotWithShape="1">
+          <a:gsLst>
+            <a:gs pos="0">
+              <a:schemeClr val="phClr">
+                <a:satMod val="103000"/>
+                <a:lumMod val="102000"/>
+                <a:tint val="94000"/>
+              </a:schemeClr>
+            </a:gs>
+            <a:gs pos="50000">
+              <a:schemeClr val="phClr">
+                <a:satMod val="110000"/>
+                <a:lumMod val="100000"/>
+                <a:shade val="100000"/>
+              </a:schemeClr>
+            </a:gs>
+            <a:gs pos="100000">
+              <a:schemeClr val="phClr">
+                <a:lumMod val="99000"/>
+                <a:satMod val="120000"/>
+                <a:shade val="78000"/>
+              </a:schemeClr>
+            </a:gs>
+          </a:gsLst>
+          <a:lin ang="5400000" scaled="0"/>
+        </a:gradFill>
+      </a:fillStyleLst>
+      <a:lnStyleLst>
+        <a:ln w="12700" cap="flat" cmpd="sng" algn="ctr">
+          <a:solidFill>
+            <a:schemeClr val="phClr"/>
+          </a:solidFill>
+          <a:prstDash val="solid"/>
+          <a:miter lim="800000"/>
+        </a:ln>
+        <a:ln w="19050" cap="flat" cmpd="sng" algn="ctr">
+          <a:solidFill>
+            <a:schemeClr val="phClr"/>
+          </a:solidFill>
+          <a:prstDash val="solid"/>
+          <a:miter lim="800000"/>
+        </a:ln>
+        <a:ln w="25400" cap="flat" cmpd="sng" algn="ctr">
+          <a:solidFill>
+            <a:schemeClr val="phClr"/>
+          </a:solidFill>
+          <a:prstDash val="solid"/>
+          <a:miter lim="800000"/>
+        </a:ln>
+      </a:lnStyleLst>
+      <a:effectStyleLst>
+        <a:effectStyle>
+          <a:effectLst/>
+        </a:effectStyle>
+        <a:effectStyle>
+          <a:effectLst/>
+        </a:effectStyle>
+        <a:effectStyle>
+          <a:effectLst>
+            <a:outerShdw blurRad="57150" dist="19050" dir="5400000" algn="ctr" rotWithShape="0">
+              <a:srgbClr val="000000">
+                <a:alpha val="63000"/>
+              </a:srgbClr>
+            </a:outerShdw>
+          </a:effectLst>
+        </a:effectStyle>
+      </a:effectStyleLst>
+      <a:bgFillStyleLst>
+        <a:solidFill>
+          <a:schemeClr val="phClr"/>
+        </a:solidFill>
+        <a:solidFill>
+          <a:schemeClr val="phClr">
+            <a:tint val="95000"/>
+            <a:satMod val="170000"/>
+          </a:schemeClr>
+        </a:solidFill>
+        <a:gradFill rotWithShape="1">
+          <a:gsLst>
+            <a:gs pos="0">
+              <a:schemeClr val="phClr">
+                <a:tint val="93000"/>
+                <a:satMod val="150000"/>
+                <a:shade val="98000"/>
+                <a:lumMod val="102000"/>
+              </a:schemeClr>
+            </a:gs>
+            <a:gs pos="50000">
+              <a:schemeClr val="phClr">
+                <a:tint val="98000"/>
+                <a:satMod val="130000"/>
+                <a:shade val="90000"/>
+                <a:lumMod val="103000"/>
+              </a:schemeClr>
+            </a:gs>
+            <a:gs pos="100000">
+              <a:schemeClr val="phClr">
+                <a:shade val="63000"/>
+                <a:satMod val="120000"/>
+              </a:schemeClr>
+            </a:gs>
+          </a:gsLst>
+          <a:lin ang="5400000" scaled="0"/>
+        </a:gradFill>
+      </a:bgFillStyleLst>
+    </a:fmtScheme>
+  </a:themeElements>
+  <a:objectDefaults>
+    <a:lnDef>
+      <a:spPr/>
+      <a:bodyPr/>
+      <a:lstStyle/>
+      <a:style>
+        <a:lnRef idx="2">
+          <a:schemeClr val="accent1"/>
+        </a:lnRef>
+        <a:fillRef idx="0">
+          <a:schemeClr val="accent1"/>
+        </a:fillRef>
+        <a:effectRef idx="1">
+          <a:schemeClr val="accent1"/>
+        </a:effectRef>
+        <a:fontRef idx="minor">
+          <a:schemeClr val="tx1"/>
+        </a:fontRef>
+      </a:style>
+    </a:lnDef>
+  </a:objectDefaults>
+  <a:extraClrSchemeLst/>
+  <a:extLst>
+    <a:ext uri="{05A4C25C-085E-4340-85A3-A5531E510DB2}">
+      <thm15:themeFamily xmlns:thm15="http://schemas.microsoft.com/office/thememl/2012/main" name="Office Theme" id="{2E142A2C-CD16-42D6-873A-C26D2A0506FA}" vid="{1BDDFF52-6CD6-40A5-AB3C-68EB2F1E4D0A}"/>
+    </a:ext>
+  </a:extLst>
+</a:theme>
 </file>
</xml_diff>

<commit_message>
Presentación regenerada con el guion final de la demo
Co-Authored-By: Claude Opus 5.5 <noreply@anthropic.com>
</commit_message>
<xml_diff>
--- a/docs/presentacion/presentacion-ml.pptx
+++ b/docs/presentacion/presentacion-ml.pptx
@@ -114,29 +114,29 @@
   <p:extLst>
     <p:ext uri="{521415D9-36F7-43E2-AB2F-B90AF26B5E84}">
       <p14:sectionLst xmlns:p14="http://schemas.microsoft.com/office/powerpoint/2010/main">
-        <p14:section name="Introducción" id="{19ea74a6-6bb7-04c4-d677-34368a59a657}">
+        <p14:section name="Introducción" id="{f556526a-4e04-cc27-3bda-c8f7f190e297}">
           <p14:sldIdLst>
             <p14:sldId id="256"/>
           </p14:sldIdLst>
         </p14:section>
-        <p14:section name="Solución" id="{a51ba35c-2115-5463-c1d8-1b7f16f08418}">
+        <p14:section name="Solución" id="{1c4c7b10-fc46-81e2-bca6-6628bb8971e0}">
           <p14:sldIdLst>
             <p14:sldId id="257"/>
             <p14:sldId id="258"/>
           </p14:sldIdLst>
         </p14:section>
-        <p14:section name="Resultados" id="{838612c4-c611-11d3-5129-615082135cdf}">
+        <p14:section name="Resultados" id="{921bcb2a-8fc5-71ca-de5d-e2051ff4bcf5}">
           <p14:sldIdLst>
             <p14:sldId id="259"/>
           </p14:sldIdLst>
         </p14:section>
-        <p14:section name="Cierre" id="{7bfc7d34-35b1-2498-bc3f-462248bb1e15}">
+        <p14:section name="Cierre" id="{fdc1b2c3-4ad8-2772-0c99-229d3df479fa}">
           <p14:sldIdLst>
             <p14:sldId id="260"/>
             <p14:sldId id="261"/>
           </p14:sldIdLst>
         </p14:section>
-        <p14:section name="Respaldo" id="{53bb5018-c2db-76e4-b0cf-c579129de68f}">
+        <p14:section name="Respaldo" id="{53948ad0-ee44-278c-5db1-1998b8a0781f}">
           <p14:sldIdLst>
             <p14:sldId id="262"/>
             <p14:sldId id="263"/>
@@ -1150,18 +1150,19 @@
 PCA + LDA llega a 83,2 %: 10 puntos más que la línea base. Y el perro correcto está entre los 3 candidatos el 93 % de las veces.
 El método y el umbral se eligieron solo con validación; la prueba se evaluó una sola vez, como un examen final.
 Ahora lo muestro funcionando."
-DEMO (antes de presentar: tener abierto http://127.0.0.1:9100 con "python run.py" o "docker compose up -d"):
-1. CASO VÁLIDO: primera foto de la fila 1 ("registrado") y pulsar "Buscar coincidencia".
+DEMO (antes de presentar: tener abierto http://127.0.0.1:9100 con "docker compose up -d" o "python run.py"):
+Las 6 fotos de ejemplo de la pestaña Buscar tienen etiqueta y siempre dan el mismo resultado.
+1. CASO VÁLIDO: foto con etiqueta "registrado" (la 1.ª) → "Buscar coincidencia".
    Resultado: reconoce a Bella (distancia 0,896 bajo el umbral 0,936).
    Decir: "Encontró a la mascota: la distancia está bajo el umbral. Aquí está su dueño y la última ubicación del collar." Pulsar "Simular nueva señal".
-2. PERRO DESCONOCIDO: PRIMERA foto de la fila 2 ("sin registro") y buscar.
-   Resultado: "Sin coincidencia" (0,969 sobre el umbral).
+2. PERRO DESCONOCIDO: foto "no registrado" (la 3.ª) → buscar.
+   Resultado: "Sin coincidencia" (Coco a 0,969, sobre el umbral).
    Decir: "Este perro no está registrado. El sistema no inventa un dueño: responde 'sin coincidencia'."
-3. LÍMITE (el error relevante que pide el enunciado): SEGUNDA foto de la fila 2 ("sin registro") y buscar.
+3. LÍMITE (el error relevante que pide el enunciado): foto "error: otro perro" → buscar.
    Resultado: acepta por error a Pancho (0,822 bajo el umbral).
-   Decir: "Aquí falla: este perro no está registrado, pero se parece muchísimo a Pancho, mismo pelaje gris y rizado, y el sistema lo acepta. Es una falsa aceptación, el 8,8 % que mencioné. Por eso la coincidencia es solo una sugerencia que se confirma con el dueño, y se muestran 3 candidatos."
-4. (Si hay tiempo) Las fotos "error del modelo" de la fila 3 son perros registrados que el sistema NO reconoce: responde "sin coincidencia" aunque sí están en la galería (falso rechazo).
-NO usar como "caso desconocido" la segunda foto de la fila 2: es justamente la que falla.
+   Decir: "Aquí falla: este perro no está registrado, pero se parece muchísimo a Pancho, mismo pelaje gris y rizado, y el sistema lo acepta. Es una falsa aceptación, el 8,8 % que mencioné. Por eso la coincidencia es solo una sugerencia y se muestran 3 candidatos."
+4. (Si hay tiempo) foto "error: no lo reconoce": Simba está registrado y sale primero, pero 1,047 supera el umbral → "sin coincidencia" (falso rechazo).
+5. (Si hay tiempo) Subir una foto propia: recuadro "Arrastra una imagen o haz clic para elegir". Fotos listas en la carpeta demo/ del proyecto (ver demo/LEEME.md): registrado (Mia), no registrado, errores, registro de una mascota nueva y archivos inválidos.
 PLAN B si algo falla: mostrar las capturas del informe (figuras 2, 3 y 4).
 CONCEPTOS:
 - Línea base: método sencillo sin entrenamiento para comparar; responde "¿mi modelo aporta algo?".
@@ -1357,7 +1358,7 @@
               <a:rPr lang="en-US" dirty="0"/>
               <a:t>TIEMPO: ~20 segundos
 QUÉ DECIR:
-"Todo el código está en el repositorio con el tag v1.0. Con 'python run.py' o con Docker se levanta el sistema completo, y hay 28 pruebas automatizadas que cubren un caso válido, casos difíciles, entradas inválidas y el flujo completo. Muchas gracias, quedo atento a sus preguntas."
+"Todo el código está en el repositorio con el tag v1.0. Con 'python run.py' o con Docker se levanta el sistema completo, y hay 29 pruebas automatizadas que cubren un caso válido, casos difíciles, entradas inválidas y el flujo completo. Muchas gracias, quedo atento a sus preguntas."
 DIAPOSITIVAS DE RESPALDO (ocultas, no se muestran al presentar): 7 = glosario, 8 = preguntas frecuentes. Para ir a una durante la presentación: escribir su número y Enter.
 POSIBLES PREGUNTAS (respuestas cortas):
 Sobre las decisiones
@@ -6769,7 +6770,7 @@
                   <a:srgbClr val="EEF4F2"/>
                 </a:solidFill>
               </a:rPr>
-              <a:t>28 pruebas: válido, difícil, inválido y flujo completo</a:t>
+              <a:t>29 pruebas: válido, difícil, inválido y flujo completo</a:t>
             </a:r>
             <a:endParaRPr lang="en-US" sz="1500" dirty="0"/>
           </a:p>

</xml_diff>